<commit_message>
docs: edit the AI advisor deck's wording in two passes
Slide text and speaker notes: staged phrasing removed (No filters to
learn, Real answers nothing scripted, Safety first, Honest limits), slide
7 retitled Guardrails, tests and limits, slide 4 spaced. Facts unchanged.
</commit_message>
<xml_diff>
--- a/docs/presentation/D4Drive-AI-Car-Advisor.pptx
+++ b/docs/presentation/D4Drive-AI-Car-Advisor.pptx
@@ -113,33 +113,33 @@
   <p:extLst>
     <p:ext uri="{521415D9-36F7-43E2-AB2F-B90AF26B5E84}">
       <p14:sectionLst xmlns:p14="http://schemas.microsoft.com/office/powerpoint/2010/main">
-        <p14:section name="Introduction" id="{7445436b-5810-a203-229a-35b3f9fec5d0}">
+        <p14:section name="Introduction" id="{2ba9cf5c-ff60-adfb-f482-812f72dc4e5a}">
           <p14:sldIdLst>
             <p14:sldId id="256"/>
           </p14:sldIdLst>
         </p14:section>
-        <p14:section name="The feature" id="{eed39102-426c-559e-0cb4-a3a540676788}">
+        <p14:section name="The feature" id="{d7e96271-82ba-e38b-aa3f-adcd7a326df3}">
           <p14:sldIdLst>
             <p14:sldId id="257"/>
           </p14:sldIdLst>
         </p14:section>
-        <p14:section name="How it works" id="{87948b43-f577-6a5b-3d2c-a812e4d92d05}">
+        <p14:section name="How it works" id="{5c6f8dd8-aaaf-410d-f8c5-32331ac212b8}">
           <p14:sldIdLst>
             <p14:sldId id="258"/>
             <p14:sldId id="259"/>
           </p14:sldIdLst>
         </p14:section>
-        <p14:section name="The database" id="{e15a3057-4d7d-ca33-1ff7-5baadc609cce}">
+        <p14:section name="The database" id="{ce38483f-c9d0-72c1-d96f-1ed572264b02}">
           <p14:sldIdLst>
             <p14:sldId id="260"/>
           </p14:sldIdLst>
         </p14:section>
-        <p14:section name="Demo" id="{647bfa0c-2134-d0ff-e6dd-93cfb5024b96}">
+        <p14:section name="Demo" id="{576219fa-2daa-adab-7878-cf3faccba983}">
           <p14:sldIdLst>
             <p14:sldId id="261"/>
           </p14:sldIdLst>
         </p14:section>
-        <p14:section name="Wrap-up" id="{86b0f559-5a81-00b4-4e7d-11c34ac920fb}">
+        <p14:section name="Wrap-up" id="{71802d66-3670-87f7-56e0-b0353d2e15ca}">
           <p14:sldIdLst>
             <p14:sldId id="262"/>
           </p14:sldIdLst>
@@ -900,7 +900,7 @@
           <a:p>
             <a:r>
               <a:rPr lang="en-US" dirty="0"/>
-              <a:t>This is where the AI meets the DBMS coursework. The model only chooses a function and its arguments. The server validates them with zod and binds them into fixed, parameterised SQL, exactly like the catalog page. check_availability reuses the stored function fn_car_available, which sp_create_booking also uses. The output on the left is real: I ran both tools against the seeded database. Five automatic cars with at least five seats, and the Honda City, named in words, is free for those three days at 7,200 rupees. A car can be named instead of numbered because the chat history keeps names, not ids; a guessed id is never trusted.</a:t>
+              <a:t>The tools are where the AI feature meets the DBMS coursework: the model only chooses a function and its arguments. The server validates them with zod and binds them into fixed, parameterised SQL, exactly like the catalog page. check_availability reuses the stored function fn_car_available, which sp_create_booking also uses. The output on the left is real: I ran both tools against the seeded database. Five automatic cars with at least five seats, and the Honda City, named in words, is free for those three days at 7,200 rupees. A car can be named instead of numbered because the chat history keeps names, not ids; a guessed id is never trusted.</a:t>
             </a:r>
             <a:endParaRPr lang="en-US" dirty="0"/>
           </a:p>
@@ -988,7 +988,7 @@
           <a:p>
             <a:r>
               <a:rPr lang="en-US" dirty="0"/>
-              <a:t>These are real, unedited answers from the running site. The visitor asks for five seats and a highway trip. While the model works, the panel says it is looking through the fleet. The reply recommends the City ZX, Seltos HTX and Creta SX at their real daily rates, all genuinely automatic, and the cards link to the car pages. Asked about dates, it checks availability by name and prices the three days at 7,200 rupees, which matches the database.</a:t>
+              <a:t>These are real, unedited answers from the running site. The visitor asks for five seats and a highway trip. While the model works, the panel says it is looking through the fleet. The reply recommends the City ZX, Seltos HTX and Creta SX at their real daily rates, all automatic, and the cards link to the car pages. Asked about dates, it checks availability by name and prices the three days at 7,200 rupees, which matches the database.</a:t>
             </a:r>
             <a:endParaRPr lang="en-US" dirty="0"/>
           </a:p>
@@ -1076,7 +1076,7 @@
           <a:p>
             <a:r>
               <a:rPr lang="en-US" dirty="0"/>
-              <a:t>Safety first: the model runs on our own server, every input is validated, the SQL is read-only and parameterised, and the server checks each draft before the visitor sees it. 72 tests pass against MySQL and the browser smoke test now includes a live answer. Honest limits: a 3 billion parameter model on a laptop CPU takes 10 to 27 seconds and can still get a description wrong, which is why the widget says the car page has the final word.</a:t>
+              <a:t>The model runs on our own server, every input is validated, the SQL is read-only and parameterised, and the server checks each draft before the visitor sees it. 72 tests pass against MySQL and the browser smoke test now includes a live answer. The limits: a 3 billion parameter model on a laptop CPU takes 10 to 27 seconds and can still get a description wrong, which is why the widget says the car page has the final word.</a:t>
             </a:r>
             <a:endParaRPr lang="en-US" dirty="0"/>
           </a:p>
@@ -2186,7 +2186,7 @@
                   <a:schemeClr val="tx2"/>
                 </a:solidFill>
               </a:rPr>
-              <a:t>“Five adults to Coorg, automatic” is enough. No filters to learn.</a:t>
+              <a:t>Type “Five adults to Coorg, automatic” instead of setting filters.</a:t>
             </a:r>
             <a:endParaRPr lang="en-US" sz="1250" dirty="0"/>
           </a:p>
@@ -3822,7 +3822,7 @@
                   <a:schemeClr val="tx1"/>
                 </a:solidFill>
               </a:rPr>
-              <a:t>A free program that runs open models on our own machine, behind a local REST API. We use qwen2.5:3b (1.9 GB): no key, no quota, no data leaves the server.</a:t>
+              <a:t>A free program that runs open models on our own machine, behind a local REST API. We use qwen2.5:3b (1.9 GB). It needs no API key or quota, and no data leaves the server.</a:t>
             </a:r>
             <a:endParaRPr lang="en-US" sz="1250" dirty="0"/>
           </a:p>
@@ -3836,7 +3836,7 @@
         </p:nvSpPr>
         <p:spPr>
           <a:xfrm>
-            <a:off x="457200" y="2176272"/>
+            <a:off x="457200" y="2331720"/>
             <a:ext cx="3840480" cy="292608"/>
           </a:xfrm>
           <a:prstGeom prst="rect">
@@ -3872,7 +3872,7 @@
         </p:nvSpPr>
         <p:spPr>
           <a:xfrm>
-            <a:off x="457200" y="2487168"/>
+            <a:off x="457200" y="2642616"/>
             <a:ext cx="3840480" cy="786384"/>
           </a:xfrm>
           <a:prstGeom prst="rect">
@@ -3908,7 +3908,7 @@
         </p:nvSpPr>
         <p:spPr>
           <a:xfrm>
-            <a:off x="457200" y="3383280"/>
+            <a:off x="457200" y="3493008"/>
             <a:ext cx="3840480" cy="292608"/>
           </a:xfrm>
           <a:prstGeom prst="rect">
@@ -3944,7 +3944,7 @@
         </p:nvSpPr>
         <p:spPr>
           <a:xfrm>
-            <a:off x="457200" y="3694176"/>
+            <a:off x="457200" y="3803904"/>
             <a:ext cx="3840480" cy="786384"/>
           </a:xfrm>
           <a:prstGeom prst="rect">
@@ -5208,7 +5208,7 @@
                   <a:schemeClr val="accent2"/>
                 </a:solidFill>
               </a:rPr>
-              <a:t>Real answers, nothing scripted: qwen2.5:3b in Ollama on this laptop’s CPU, against the seeded fleet. Each reply took 10 to 27 seconds.</a:t>
+              <a:t>Real, unedited answers from qwen2.5:3b in Ollama on this laptop’s CPU, against the seeded fleet. Each reply took 10 to 27 seconds.</a:t>
             </a:r>
             <a:endParaRPr lang="en-US" sz="1100" dirty="0"/>
           </a:p>
@@ -5587,7 +5587,7 @@
                 <a:ea typeface="Cambria" pitchFamily="34" charset="-122"/>
                 <a:cs typeface="Cambria" pitchFamily="34" charset="-120"/>
               </a:rPr>
-              <a:t>Guardrails, tests and what is next</a:t>
+              <a:t>Guardrails, tests and limits</a:t>
             </a:r>
             <a:endParaRPr lang="en-US" sz="3200" dirty="0"/>
           </a:p>
@@ -5928,7 +5928,7 @@
                   <a:schemeClr val="accent3"/>
                 </a:solidFill>
               </a:rPr>
-              <a:t>Honest limits</a:t>
+              <a:t>Limits</a:t>
             </a:r>
             <a:endParaRPr lang="en-US" sz="1300" dirty="0"/>
           </a:p>

</xml_diff>

<commit_message>
docs: the deck's byline is Rohit Sham, 24BDE0129
</commit_message>
<xml_diff>
--- a/docs/presentation/D4Drive-AI-Car-Advisor.pptx
+++ b/docs/presentation/D4Drive-AI-Car-Advisor.pptx
@@ -4,6 +4,9 @@
   <p:sldMasterIdLst>
     <p:sldMasterId id="2147483648" r:id="rId1"/>
   </p:sldMasterIdLst>
+  <p:notesMasterIdLst>
+    <p:notesMasterId r:id="rId9"/>
+  </p:notesMasterIdLst>
   <p:sldIdLst>
     <p:sldId id="256" r:id="rId2"/>
     <p:sldId id="257" r:id="rId3"/>
@@ -13,10 +16,7 @@
     <p:sldId id="261" r:id="rId7"/>
     <p:sldId id="262" r:id="rId8"/>
   </p:sldIdLst>
-  <p:notesMasterIdLst>
-    <p:notesMasterId r:id="rId9"/>
-  </p:notesMasterIdLst>
-  <p:sldSz cx="9144000" cy="5143500"/>
+  <p:sldSz cx="9144000" cy="5143500" type="screen16x9"/>
   <p:notesSz cx="5143500" cy="9144000"/>
   <p:defaultTextStyle>
     <a:lvl1pPr marL="0" algn="l" defTabSz="914400" rtl="0" eaLnBrk="1" latinLnBrk="0" hangingPunct="1">
@@ -113,33 +113,33 @@
   <p:extLst>
     <p:ext uri="{521415D9-36F7-43E2-AB2F-B90AF26B5E84}">
       <p14:sectionLst xmlns:p14="http://schemas.microsoft.com/office/powerpoint/2010/main">
-        <p14:section name="Introduction" id="{2ba9cf5c-ff60-adfb-f482-812f72dc4e5a}">
+        <p14:section name="Introduction" id="{2BA9CF5C-FF60-ADFB-F482-812F72DC4E5A}">
           <p14:sldIdLst>
             <p14:sldId id="256"/>
           </p14:sldIdLst>
         </p14:section>
-        <p14:section name="The feature" id="{d7e96271-82ba-e38b-aa3f-adcd7a326df3}">
+        <p14:section name="The feature" id="{D7E96271-82BA-E38B-AA3F-ADCD7A326DF3}">
           <p14:sldIdLst>
             <p14:sldId id="257"/>
           </p14:sldIdLst>
         </p14:section>
-        <p14:section name="How it works" id="{5c6f8dd8-aaaf-410d-f8c5-32331ac212b8}">
+        <p14:section name="How it works" id="{5C6F8DD8-AAAF-410D-F8C5-32331AC212B8}">
           <p14:sldIdLst>
             <p14:sldId id="258"/>
             <p14:sldId id="259"/>
           </p14:sldIdLst>
         </p14:section>
-        <p14:section name="The database" id="{ce38483f-c9d0-72c1-d96f-1ed572264b02}">
+        <p14:section name="The database" id="{CE38483F-C9D0-72C1-D96F-1ED572264B02}">
           <p14:sldIdLst>
             <p14:sldId id="260"/>
           </p14:sldIdLst>
         </p14:section>
-        <p14:section name="Demo" id="{576219fa-2daa-adab-7878-cf3faccba983}">
+        <p14:section name="Demo" id="{576219FA-2DAA-ADAB-7878-CF3FACCBA983}">
           <p14:sldIdLst>
             <p14:sldId id="261"/>
           </p14:sldIdLst>
         </p14:section>
-        <p14:section name="Wrap-up" id="{71802d66-3670-87f7-56e0-b0353d2e15ca}">
+        <p14:section name="Wrap-up" id="{71802D66-3670-87F7-56E0-B0353D2E15CA}">
           <p14:sldIdLst>
             <p14:sldId id="262"/>
           </p14:sldIdLst>
@@ -175,234 +175,10 @@
           <a:chExt cx="0" cy="0"/>
         </a:xfrm>
       </p:grpSpPr>
-      <p:sp>
-        <p:nvSpPr>
-          <p:cNvPr id="2" name="Header Placeholder 1"/>
-          <p:cNvSpPr>
-            <a:spLocks noGrp="1"/>
-          </p:cNvSpPr>
-          <p:nvPr>
-            <p:ph type="hdr" sz="quarter"/>
-          </p:nvPr>
-        </p:nvSpPr>
-        <p:spPr>
-          <a:xfrm>
-            <a:off x="0" y="0"/>
-            <a:ext cx="2971800" cy="458788"/>
-          </a:xfrm>
-          <a:prstGeom prst="rect">
-            <a:avLst/>
-          </a:prstGeom>
-        </p:spPr>
-        <p:txBody>
-          <a:bodyPr vert="horz" lIns="91440" tIns="45720" rIns="91440" bIns="45720" rtlCol="0"/>
-          <a:lstStyle>
-            <a:lvl1pPr algn="l">
-              <a:defRPr sz="1200"/>
-            </a:lvl1pPr>
-          </a:lstStyle>
-          <a:p>
-            <a:endParaRPr lang="en-US"/>
-          </a:p>
-        </p:txBody>
-      </p:sp>
-      <p:sp>
-        <p:nvSpPr>
-          <p:cNvPr id="3" name="Date Placeholder 2"/>
-          <p:cNvSpPr>
-            <a:spLocks noGrp="1"/>
-          </p:cNvSpPr>
-          <p:nvPr>
-            <p:ph type="dt" idx="1"/>
-          </p:nvPr>
-        </p:nvSpPr>
-        <p:spPr>
-          <a:xfrm>
-            <a:off x="3884613" y="0"/>
-            <a:ext cx="2971800" cy="458788"/>
-          </a:xfrm>
-          <a:prstGeom prst="rect">
-            <a:avLst/>
-          </a:prstGeom>
-        </p:spPr>
-        <p:txBody>
-          <a:bodyPr vert="horz" lIns="91440" tIns="45720" rIns="91440" bIns="45720" rtlCol="0"/>
-          <a:lstStyle>
-            <a:lvl1pPr algn="r">
-              <a:defRPr sz="1200"/>
-            </a:lvl1pPr>
-          </a:lstStyle>
-          <a:p>
-            <a:fld id="{5282F153-3F37-0F45-9E97-73ACFA13230C}" type="datetimeFigureOut">
-              <a:rPr lang="en-US"/>
-              <a:t>7/23/19</a:t>
-            </a:fld>
-            <a:endParaRPr lang="en-US"/>
-          </a:p>
-        </p:txBody>
-      </p:sp>
-      <p:sp>
-        <p:nvSpPr>
-          <p:cNvPr id="4" name="Slide Image Placeholder 3"/>
-          <p:cNvSpPr>
-            <a:spLocks noGrp="1" noRot="1" noChangeAspect="1"/>
-          </p:cNvSpPr>
-          <p:nvPr>
-            <p:ph type="sldImg" idx="2"/>
-          </p:nvPr>
-        </p:nvSpPr>
-        <p:spPr>
-          <a:xfrm>
-            <a:off x="685800" y="1143000"/>
-            <a:ext cx="5486400" cy="3086100"/>
-          </a:xfrm>
-          <a:prstGeom prst="rect">
-            <a:avLst/>
-          </a:prstGeom>
-          <a:noFill/>
-          <a:ln w="12700">
-            <a:solidFill>
-              <a:prstClr val="black"/>
-            </a:solidFill>
-          </a:ln>
-        </p:spPr>
-        <p:txBody>
-          <a:bodyPr vert="horz" lIns="91440" tIns="45720" rIns="91440" bIns="45720" rtlCol="0" anchor="ctr"/>
-          <a:lstStyle/>
-          <a:p>
-            <a:endParaRPr lang="en-US"/>
-          </a:p>
-        </p:txBody>
-      </p:sp>
-      <p:sp>
-        <p:nvSpPr>
-          <p:cNvPr id="5" name="Notes Placeholder 4"/>
-          <p:cNvSpPr>
-            <a:spLocks noGrp="1"/>
-          </p:cNvSpPr>
-          <p:nvPr>
-            <p:ph type="body" sz="quarter" idx="3"/>
-          </p:nvPr>
-        </p:nvSpPr>
-        <p:spPr>
-          <a:xfrm>
-            <a:off x="685800" y="4400550"/>
-            <a:ext cx="5486400" cy="3600450"/>
-          </a:xfrm>
-          <a:prstGeom prst="rect">
-            <a:avLst/>
-          </a:prstGeom>
-        </p:spPr>
-        <p:txBody>
-          <a:bodyPr vert="horz" lIns="91440" tIns="45720" rIns="91440" bIns="45720" rtlCol="0"/>
-          <a:lstStyle/>
-          <a:p>
-            <a:pPr lvl="0"/>
-            <a:r>
-              <a:rPr lang="en-US"/>
-              <a:t>Click to edit Master text styles</a:t>
-            </a:r>
-          </a:p>
-          <a:p>
-            <a:pPr lvl="1"/>
-            <a:r>
-              <a:rPr lang="en-US"/>
-              <a:t>Second level</a:t>
-            </a:r>
-          </a:p>
-          <a:p>
-            <a:pPr lvl="2"/>
-            <a:r>
-              <a:rPr lang="en-US"/>
-              <a:t>Third level</a:t>
-            </a:r>
-          </a:p>
-          <a:p>
-            <a:pPr lvl="3"/>
-            <a:r>
-              <a:rPr lang="en-US"/>
-              <a:t>Fourth level</a:t>
-            </a:r>
-          </a:p>
-          <a:p>
-            <a:pPr lvl="4"/>
-            <a:r>
-              <a:rPr lang="en-US"/>
-              <a:t>Fifth level</a:t>
-            </a:r>
-          </a:p>
-        </p:txBody>
-      </p:sp>
-      <p:sp>
-        <p:nvSpPr>
-          <p:cNvPr id="6" name="Footer Placeholder 5"/>
-          <p:cNvSpPr>
-            <a:spLocks noGrp="1"/>
-          </p:cNvSpPr>
-          <p:nvPr>
-            <p:ph type="ftr" sz="quarter" idx="4"/>
-          </p:nvPr>
-        </p:nvSpPr>
-        <p:spPr>
-          <a:xfrm>
-            <a:off x="0" y="8685213"/>
-            <a:ext cx="2971800" cy="458787"/>
-          </a:xfrm>
-          <a:prstGeom prst="rect">
-            <a:avLst/>
-          </a:prstGeom>
-        </p:spPr>
-        <p:txBody>
-          <a:bodyPr vert="horz" lIns="91440" tIns="45720" rIns="91440" bIns="45720" rtlCol="0" anchor="b"/>
-          <a:lstStyle>
-            <a:lvl1pPr algn="l">
-              <a:defRPr sz="1200"/>
-            </a:lvl1pPr>
-          </a:lstStyle>
-          <a:p>
-            <a:endParaRPr lang="en-US"/>
-          </a:p>
-        </p:txBody>
-      </p:sp>
-      <p:sp>
-        <p:nvSpPr>
-          <p:cNvPr id="7" name="Slide Number Placeholder 6"/>
-          <p:cNvSpPr>
-            <a:spLocks noGrp="1"/>
-          </p:cNvSpPr>
-          <p:nvPr>
-            <p:ph type="sldNum" sz="quarter" idx="5"/>
-          </p:nvPr>
-        </p:nvSpPr>
-        <p:spPr>
-          <a:xfrm>
-            <a:off x="3884613" y="8685213"/>
-            <a:ext cx="2971800" cy="458787"/>
-          </a:xfrm>
-          <a:prstGeom prst="rect">
-            <a:avLst/>
-          </a:prstGeom>
-        </p:spPr>
-        <p:txBody>
-          <a:bodyPr vert="horz" lIns="91440" tIns="45720" rIns="91440" bIns="45720" rtlCol="0" anchor="b"/>
-          <a:lstStyle>
-            <a:lvl1pPr algn="r">
-              <a:defRPr sz="1200"/>
-            </a:lvl1pPr>
-          </a:lstStyle>
-          <a:p>
-            <a:fld id="{CE5E9CC1-C706-0F49-92D6-E571CC5EEA8F}" type="slidenum">
-              <a:rPr lang="en-US"/>
-              <a:t>‹#›</a:t>
-            </a:fld>
-            <a:endParaRPr lang="en-US"/>
-          </a:p>
-        </p:txBody>
-      </p:sp>
     </p:spTree>
     <p:extLst>
       <p:ext uri="{BB962C8B-B14F-4D97-AF65-F5344CB8AC3E}">
-        <p14:creationId xmlns:p14="http://schemas.microsoft.com/office/powerpoint/2010/main" val="1024086991"/>
+        <p14:creationId xmlns:p14="http://schemas.microsoft.com/office/powerpoint/2010/main" val="642440597"/>
       </p:ext>
     </p:extLst>
   </p:cSld>
@@ -550,7 +326,6 @@
               <a:rPr lang="en-US" dirty="0"/>
               <a:t>D4Drive is our car rental and doorstep delivery site for Bengaluru. For the AI feature I added a car advisor: a chat button on every public page. You describe your trip in plain words and it recommends cars from our real fleet, with real prices. The AI is an open model, qwen2.5:3b, running on this machine through Ollama, and it gets its facts from two tools that query our MySQL database.</a:t>
             </a:r>
-            <a:endParaRPr lang="en-US" dirty="0"/>
           </a:p>
         </p:txBody>
       </p:sp>
@@ -638,7 +413,6 @@
               <a:rPr lang="en-US" dirty="0"/>
               <a:t>What it does: the visitor types what they need, the advisor searches the fleet and answers in a few sentences with up to three cars. Each car card links to its page, where Reserve starts the normal booking. The widget lives in the root layout, so the conversation survives moving between pages.</a:t>
             </a:r>
-            <a:endParaRPr lang="en-US" dirty="0"/>
           </a:p>
         </p:txBody>
       </p:sp>
@@ -726,7 +500,6 @@
               <a:rPr lang="en-US" dirty="0"/>
               <a:t>The browser only ever calls our own route. The route sends the conversation to Ollama on localhost with two tool definitions. The model does not touch the database: when it needs facts it replies with a tool call, our server runs that tool against MySQL and returns the rows, and the model writes the answer from them. Before a reply is shown, the server checks it: no cars or prices before a search, and every rupee amount must be one the tools returned. Nothing leaves our server.</a:t>
             </a:r>
-            <a:endParaRPr lang="en-US" dirty="0"/>
           </a:p>
         </p:txBody>
       </p:sp>
@@ -814,7 +587,6 @@
               <a:rPr lang="en-US" dirty="0"/>
               <a:t>Ollama downloads open models and serves them on localhost port 11434. A language model on its own only predicts text, so it could invent a car or a price, and our first test run did exactly that. Tool calling gives it a way to ask for facts: we declare search_fleet and check_availability, and when the model needs data it returns a structured call instead of prose. Our code runs it and hands back the result as a tool message. Because a small model still cuts corners, the server checks each draft before the visitor sees it and sends it back with a correction if it is not grounded.</a:t>
             </a:r>
-            <a:endParaRPr lang="en-US" dirty="0"/>
           </a:p>
         </p:txBody>
       </p:sp>
@@ -902,7 +674,6 @@
               <a:rPr lang="en-US" dirty="0"/>
               <a:t>The tools are where the AI feature meets the DBMS coursework: the model only chooses a function and its arguments. The server validates them with zod and binds them into fixed, parameterised SQL, exactly like the catalog page. check_availability reuses the stored function fn_car_available, which sp_create_booking also uses. The output on the left is real: I ran both tools against the seeded database. Five automatic cars with at least five seats, and the Honda City, named in words, is free for those three days at 7,200 rupees. A car can be named instead of numbered because the chat history keeps names, not ids; a guessed id is never trusted.</a:t>
             </a:r>
-            <a:endParaRPr lang="en-US" dirty="0"/>
           </a:p>
         </p:txBody>
       </p:sp>
@@ -990,7 +761,6 @@
               <a:rPr lang="en-US" dirty="0"/>
               <a:t>These are real, unedited answers from the running site. The visitor asks for five seats and a highway trip. While the model works, the panel says it is looking through the fleet. The reply recommends the City ZX, Seltos HTX and Creta SX at their real daily rates, all automatic, and the cards link to the car pages. Asked about dates, it checks availability by name and prices the three days at 7,200 rupees, which matches the database.</a:t>
             </a:r>
-            <a:endParaRPr lang="en-US" dirty="0"/>
           </a:p>
         </p:txBody>
       </p:sp>
@@ -1078,7 +848,6 @@
               <a:rPr lang="en-US" dirty="0"/>
               <a:t>The model runs on our own server, every input is validated, the SQL is read-only and parameterised, and the server checks each draft before the visitor sees it. 72 tests pass against MySQL and the browser smoke test now includes a live answer. The limits: a 3 billion parameter model on a laptop CPU takes 10 to 27 seconds and can still get a description wrong, which is why the widget says the car page has the final word.</a:t>
             </a:r>
-            <a:endParaRPr lang="en-US" dirty="0"/>
           </a:p>
         </p:txBody>
       </p:sp>
@@ -1156,6 +925,7 @@
         <a:solidFill>
           <a:srgbClr val="1A1A1A"/>
         </a:solidFill>
+        <a:effectLst/>
       </p:bgPr>
     </p:bg>
     <p:spTree>
@@ -1188,6 +958,7 @@
         <a:solidFill>
           <a:srgbClr val="BDBCBA"/>
         </a:solidFill>
+        <a:effectLst/>
       </p:bgPr>
     </p:bg>
     <p:spTree>
@@ -1207,9 +978,11 @@
       <p:sp>
         <p:nvSpPr>
           <p:cNvPr id="2" name="Text 0"/>
-          <p:cNvSpPr/>
+          <p:cNvSpPr>
+            <a:spLocks noGrp="1"/>
+          </p:cNvSpPr>
           <p:nvPr>
-            <p:ph idx="100" type="title" hasCustomPrompt="1"/>
+            <p:ph type="title" idx="100" hasCustomPrompt="1"/>
           </p:nvPr>
         </p:nvSpPr>
         <p:spPr>
@@ -1226,7 +999,7 @@
         <p:txBody>
           <a:bodyPr wrap="square" rtlCol="0"/>
           <a:lstStyle>
-            <a:lvl1pPr algn="l" indent="0" marL="0">
+            <a:lvl1pPr marL="0" indent="0" algn="l">
               <a:buNone/>
               <a:defRPr lang="en-US" sz="3200" b="1" dirty="0">
                 <a:solidFill>
@@ -1239,7 +1012,7 @@
             </a:lvl1pPr>
           </a:lstStyle>
           <a:p>
-            <a:pPr algn="l" indent="0" marL="0">
+            <a:pPr marL="0" indent="0" algn="l">
               <a:buNone/>
             </a:pPr>
             <a:endParaRPr lang="en-US" sz="3200" dirty="0"/>
@@ -1267,7 +1040,7 @@
           <a:bodyPr wrap="square" lIns="0" tIns="0" rIns="0" bIns="0" rtlCol="0" anchor="ctr"/>
           <a:lstStyle/>
           <a:p>
-            <a:pPr indent="0" marL="0">
+            <a:pPr marL="0" indent="0">
               <a:buNone/>
             </a:pPr>
             <a:r>
@@ -1302,7 +1075,7 @@
           </a:prstGeom>
           <a:extLst>
             <a:ext uri="{C572A759-6A51-4108-AA02-DFA0A04FC94B}">
-              <ma14:wrappingTextBoxFlag xmlns:ma14="http://schemas.microsoft.com/office/mac/drawingml/2011/main" val="0"/>
+              <ma14:wrappingTextBoxFlag xmlns:ma14="http://schemas.microsoft.com/office/mac/drawingml/2011/main" xmlns="" val="0"/>
             </a:ext>
           </a:extLst>
         </p:spPr>
@@ -1320,8 +1093,8 @@
           <a:p>
             <a:pPr algn="r"/>
             <a:fld id="{F7021451-1387-4CA6-816F-3879F97B5CBC}" type="slidenum">
-              <a:rPr b="0" lang="en-US"/>
-              <a:t>1003</a:t>
+              <a:rPr lang="en-US" b="0"/>
+              <a:t>‹#›</a:t>
             </a:fld>
             <a:endParaRPr lang="en-US"/>
           </a:p>
@@ -1343,6 +1116,7 @@
         <a:solidFill>
           <a:srgbClr val="1A1A1A"/>
         </a:solidFill>
+        <a:effectLst/>
       </p:bgPr>
     </p:bg>
     <p:spTree>
@@ -1362,9 +1136,11 @@
       <p:sp>
         <p:nvSpPr>
           <p:cNvPr id="2" name="Text 0"/>
-          <p:cNvSpPr/>
+          <p:cNvSpPr>
+            <a:spLocks noGrp="1"/>
+          </p:cNvSpPr>
           <p:nvPr>
-            <p:ph idx="100" type="title" hasCustomPrompt="1"/>
+            <p:ph type="title" idx="100" hasCustomPrompt="1"/>
           </p:nvPr>
         </p:nvSpPr>
         <p:spPr>
@@ -1381,7 +1157,7 @@
         <p:txBody>
           <a:bodyPr wrap="square" rtlCol="0"/>
           <a:lstStyle>
-            <a:lvl1pPr algn="l" indent="0" marL="0">
+            <a:lvl1pPr marL="0" indent="0" algn="l">
               <a:buNone/>
               <a:defRPr lang="en-US" sz="3200" b="1" dirty="0">
                 <a:solidFill>
@@ -1394,7 +1170,7 @@
             </a:lvl1pPr>
           </a:lstStyle>
           <a:p>
-            <a:pPr algn="l" indent="0" marL="0">
+            <a:pPr marL="0" indent="0" algn="l">
               <a:buNone/>
             </a:pPr>
             <a:endParaRPr lang="en-US" sz="3200" dirty="0"/>
@@ -1422,7 +1198,7 @@
           <a:bodyPr wrap="square" lIns="0" tIns="0" rIns="0" bIns="0" rtlCol="0" anchor="ctr"/>
           <a:lstStyle/>
           <a:p>
-            <a:pPr indent="0" marL="0">
+            <a:pPr marL="0" indent="0">
               <a:buNone/>
             </a:pPr>
             <a:r>
@@ -1457,7 +1233,7 @@
           </a:prstGeom>
           <a:extLst>
             <a:ext uri="{C572A759-6A51-4108-AA02-DFA0A04FC94B}">
-              <ma14:wrappingTextBoxFlag xmlns:ma14="http://schemas.microsoft.com/office/mac/drawingml/2011/main" val="0"/>
+              <ma14:wrappingTextBoxFlag xmlns:ma14="http://schemas.microsoft.com/office/mac/drawingml/2011/main" xmlns="" val="0"/>
             </a:ext>
           </a:extLst>
         </p:spPr>
@@ -1475,8 +1251,8 @@
           <a:p>
             <a:pPr algn="r"/>
             <a:fld id="{F7021451-1387-4CA6-816F-3879F97B5CBC}" type="slidenum">
-              <a:rPr b="0" lang="en-US"/>
-              <a:t>1004</a:t>
+              <a:rPr lang="en-US" b="0"/>
+              <a:t>‹#›</a:t>
             </a:fld>
             <a:endParaRPr lang="en-US"/>
           </a:p>
@@ -1493,6 +1269,11 @@
 <file path=ppt/slideMasters/slideMaster1.xml><?xml version="1.0" encoding="utf-8"?>
 <p:sldMaster xmlns:a="http://schemas.openxmlformats.org/drawingml/2006/main" xmlns:r="http://schemas.openxmlformats.org/officeDocument/2006/relationships" xmlns:p="http://schemas.openxmlformats.org/presentationml/2006/main">
   <p:cSld>
+    <p:bg>
+      <p:bgRef idx="1001">
+        <a:schemeClr val="bg1"/>
+      </p:bgRef>
+    </p:bg>
     <p:spTree>
       <p:nvGrpSpPr>
         <p:cNvPr id="1" name=""/>
@@ -1527,7 +1308,7 @@
           </a:prstGeom>
           <a:extLst>
             <a:ext uri="{C572A759-6A51-4108-AA02-DFA0A04FC94B}">
-              <ma14:wrappingTextBoxFlag xmlns:ma14="http://schemas.microsoft.com/office/mac/drawingml/2011/main" val="0"/>
+              <ma14:wrappingTextBoxFlag xmlns:ma14="http://schemas.microsoft.com/office/mac/drawingml/2011/main" xmlns="" val="0"/>
             </a:ext>
           </a:extLst>
         </p:spPr>
@@ -1545,8 +1326,8 @@
           <a:p>
             <a:pPr algn="r"/>
             <a:fld id="{F7021451-1387-4CA6-816F-3879F97B5CBC}" type="slidenum">
-              <a:rPr b="0" lang="en-US"/>
-              <a:t>null</a:t>
+              <a:rPr lang="en-US" b="0"/>
+              <a:t>‹#›</a:t>
             </a:fld>
             <a:endParaRPr lang="en-US"/>
           </a:p>
@@ -1853,11 +1634,11 @@
           <a:bodyPr wrap="square" lIns="0" tIns="0" rIns="0" bIns="0" rtlCol="0" anchor="ctr"/>
           <a:lstStyle/>
           <a:p>
-            <a:pPr indent="0" marL="0">
-              <a:buNone/>
-            </a:pPr>
-            <a:r>
-              <a:rPr lang="en-US" sz="1200" b="1" spc="200" kern="0" dirty="0">
+            <a:pPr marL="0" indent="0">
+              <a:buNone/>
+            </a:pPr>
+            <a:r>
+              <a:rPr lang="en-US" sz="1200" b="1" kern="0" spc="200" dirty="0">
                 <a:solidFill>
                   <a:schemeClr val="accent3"/>
                 </a:solidFill>
@@ -1889,7 +1670,7 @@
           <a:bodyPr wrap="square" lIns="0" tIns="0" rIns="0" bIns="0" rtlCol="0" anchor="t"/>
           <a:lstStyle/>
           <a:p>
-            <a:pPr indent="0" marL="0">
+            <a:pPr marL="0" indent="0">
               <a:buNone/>
             </a:pPr>
             <a:r>
@@ -1928,7 +1709,7 @@
           <a:bodyPr wrap="square" lIns="0" tIns="0" rIns="0" bIns="0" rtlCol="0" anchor="t"/>
           <a:lstStyle/>
           <a:p>
-            <a:pPr indent="0" marL="0">
+            <a:pPr marL="0" indent="0">
               <a:buNone/>
             </a:pPr>
             <a:r>
@@ -1964,7 +1745,7 @@
           <a:bodyPr wrap="square" lIns="0" tIns="0" rIns="0" bIns="0" rtlCol="0" anchor="ctr"/>
           <a:lstStyle/>
           <a:p>
-            <a:pPr indent="0" marL="0">
+            <a:pPr marL="0" indent="0">
               <a:buNone/>
             </a:pPr>
             <a:r>
@@ -1973,7 +1754,20 @@
                   <a:schemeClr val="accent3"/>
                 </a:solidFill>
               </a:rPr>
-              <a:t>Rohit  |  D4Drive DBMS project  |  October 2026</a:t>
+              <a:t>Rohit Sham </a:t>
+            </a:r>
+          </a:p>
+          <a:p>
+            <a:pPr marL="0" indent="0">
+              <a:buNone/>
+            </a:pPr>
+            <a:r>
+              <a:rPr lang="en-US" sz="1200" dirty="0">
+                <a:solidFill>
+                  <a:schemeClr val="accent3"/>
+                </a:solidFill>
+              </a:rPr>
+              <a:t>24BDE0129</a:t>
             </a:r>
             <a:endParaRPr lang="en-US" sz="1200" dirty="0"/>
           </a:p>
@@ -1981,14 +1775,14 @@
       </p:sp>
       <p:pic>
         <p:nvPicPr>
-          <p:cNvPr id="6" name="The advisor open on a phone" descr="The advisor open on a phone">    </p:cNvPr>
+          <p:cNvPr id="6" name="The advisor open on a phone" descr="The advisor open on a phone"/>
           <p:cNvPicPr>
             <a:picLocks noChangeAspect="1"/>
           </p:cNvPicPr>
           <p:nvPr/>
         </p:nvPicPr>
         <p:blipFill>
-          <a:blip r:embed="rId1"/>
+          <a:blip r:embed="rId3"/>
           <a:stretch>
             <a:fillRect/>
           </a:stretch>
@@ -2002,7 +1796,7 @@
             <a:avLst/>
           </a:prstGeom>
           <a:effectLst>
-            <a:outerShdw sx="100000" sy="100000" kx="0" ky="0" algn="bl" rotWithShape="0" blurRad="127000" dist="38100" dir="5400000">
+            <a:outerShdw blurRad="127000" dist="38100" dir="5400000" algn="bl" rotWithShape="0">
               <a:srgbClr val="1A1A1A">
                 <a:alpha val="28000"/>
               </a:srgbClr>
@@ -2038,9 +1832,11 @@
       <p:sp>
         <p:nvSpPr>
           <p:cNvPr id="2" name="Text 0"/>
-          <p:cNvSpPr/>
+          <p:cNvSpPr>
+            <a:spLocks noGrp="1"/>
+          </p:cNvSpPr>
           <p:nvPr>
-            <p:ph idx="100" type="title" hasCustomPrompt="1"/>
+            <p:ph type="title" idx="100" hasCustomPrompt="1"/>
           </p:nvPr>
         </p:nvSpPr>
         <p:spPr>
@@ -2058,7 +1854,7 @@
           <a:bodyPr wrap="square" lIns="0" tIns="0" rIns="0" bIns="0" rtlCol="0" anchor="ctr"/>
           <a:lstStyle/>
           <a:p>
-            <a:pPr algn="l" indent="0" marL="0">
+            <a:pPr marL="0" indent="0" algn="l">
               <a:buNone/>
             </a:pPr>
             <a:r>
@@ -2095,242 +1891,17 @@
           </a:solidFill>
           <a:ln/>
         </p:spPr>
+        <p:txBody>
+          <a:bodyPr/>
+          <a:lstStyle/>
+          <a:p>
+            <a:endParaRPr lang="en-AE"/>
+          </a:p>
+        </p:txBody>
       </p:sp>
       <p:pic>
         <p:nvPicPr>
-          <p:cNvPr id="4" name="Ask in plain words icon" descr="preencoded.png">    </p:cNvPr>
-          <p:cNvPicPr>
-            <a:picLocks noChangeAspect="1"/>
-          </p:cNvPicPr>
-          <p:nvPr/>
-        </p:nvPicPr>
-        <p:blipFill>
-          <a:blip r:embed="rId1"/>
-          <a:stretch>
-            <a:fillRect/>
-          </a:stretch>
-        </p:blipFill>
-        <p:spPr>
-          <a:xfrm>
-            <a:off x="557784" y="1289304"/>
-            <a:ext cx="256032" cy="256032"/>
-          </a:xfrm>
-          <a:prstGeom prst="rect">
-            <a:avLst/>
-          </a:prstGeom>
-        </p:spPr>
-      </p:pic>
-      <p:sp>
-        <p:nvSpPr>
-          <p:cNvPr id="5" name="Ask in plain words heading"/>
-          <p:cNvSpPr txBox="1"/>
-          <p:nvPr/>
-        </p:nvSpPr>
-        <p:spPr>
-          <a:xfrm>
-            <a:off x="1097280" y="1152144"/>
-            <a:ext cx="2834640" cy="292608"/>
-          </a:xfrm>
-          <a:prstGeom prst="rect">
-            <a:avLst/>
-          </a:prstGeom>
-          <a:noFill/>
-          <a:ln/>
-        </p:spPr>
-        <p:txBody>
-          <a:bodyPr wrap="square" lIns="0" tIns="0" rIns="0" bIns="0" rtlCol="0" anchor="ctr"/>
-          <a:lstStyle/>
-          <a:p>
-            <a:pPr indent="0" marL="0">
-              <a:buNone/>
-            </a:pPr>
-            <a:r>
-              <a:rPr lang="en-US" sz="1500" b="1" dirty="0">
-                <a:solidFill>
-                  <a:schemeClr val="tx1"/>
-                </a:solidFill>
-              </a:rPr>
-              <a:t>Ask in plain words</a:t>
-            </a:r>
-            <a:endParaRPr lang="en-US" sz="1500" dirty="0"/>
-          </a:p>
-        </p:txBody>
-      </p:sp>
-      <p:sp>
-        <p:nvSpPr>
-          <p:cNvPr id="6" name="Ask in plain words text"/>
-          <p:cNvSpPr txBox="1"/>
-          <p:nvPr/>
-        </p:nvSpPr>
-        <p:spPr>
-          <a:xfrm>
-            <a:off x="1097280" y="1444752"/>
-            <a:ext cx="2834640" cy="530352"/>
-          </a:xfrm>
-          <a:prstGeom prst="rect">
-            <a:avLst/>
-          </a:prstGeom>
-          <a:noFill/>
-          <a:ln/>
-        </p:spPr>
-        <p:txBody>
-          <a:bodyPr wrap="square" lIns="0" tIns="0" rIns="0" bIns="0" rtlCol="0" anchor="t"/>
-          <a:lstStyle/>
-          <a:p>
-            <a:pPr indent="0" marL="0">
-              <a:buNone/>
-            </a:pPr>
-            <a:r>
-              <a:rPr lang="en-US" sz="1250" dirty="0">
-                <a:solidFill>
-                  <a:schemeClr val="tx2"/>
-                </a:solidFill>
-              </a:rPr>
-              <a:t>Type “Five adults to Coorg, automatic” instead of setting filters.</a:t>
-            </a:r>
-            <a:endParaRPr lang="en-US" sz="1250" dirty="0"/>
-          </a:p>
-        </p:txBody>
-      </p:sp>
-      <p:sp>
-        <p:nvSpPr>
-          <p:cNvPr id="7" name="Answers from the live fleet badge"/>
-          <p:cNvSpPr/>
-          <p:nvPr/>
-        </p:nvSpPr>
-        <p:spPr>
-          <a:xfrm>
-            <a:off x="457200" y="2057400"/>
-            <a:ext cx="457200" cy="457200"/>
-          </a:xfrm>
-          <a:prstGeom prst="rect">
-            <a:avLst/>
-          </a:prstGeom>
-          <a:solidFill>
-            <a:schemeClr val="accent1"/>
-          </a:solidFill>
-          <a:ln/>
-        </p:spPr>
-      </p:sp>
-      <p:pic>
-        <p:nvPicPr>
-          <p:cNvPr id="8" name="Answers from the live fleet icon" descr="preencoded.png">    </p:cNvPr>
-          <p:cNvPicPr>
-            <a:picLocks noChangeAspect="1"/>
-          </p:cNvPicPr>
-          <p:nvPr/>
-        </p:nvPicPr>
-        <p:blipFill>
-          <a:blip r:embed="rId2"/>
-          <a:stretch>
-            <a:fillRect/>
-          </a:stretch>
-        </p:blipFill>
-        <p:spPr>
-          <a:xfrm>
-            <a:off x="557784" y="2157984"/>
-            <a:ext cx="256032" cy="256032"/>
-          </a:xfrm>
-          <a:prstGeom prst="rect">
-            <a:avLst/>
-          </a:prstGeom>
-        </p:spPr>
-      </p:pic>
-      <p:sp>
-        <p:nvSpPr>
-          <p:cNvPr id="9" name="Answers from the live fleet heading"/>
-          <p:cNvSpPr txBox="1"/>
-          <p:nvPr/>
-        </p:nvSpPr>
-        <p:spPr>
-          <a:xfrm>
-            <a:off x="1097280" y="2020824"/>
-            <a:ext cx="2834640" cy="292608"/>
-          </a:xfrm>
-          <a:prstGeom prst="rect">
-            <a:avLst/>
-          </a:prstGeom>
-          <a:noFill/>
-          <a:ln/>
-        </p:spPr>
-        <p:txBody>
-          <a:bodyPr wrap="square" lIns="0" tIns="0" rIns="0" bIns="0" rtlCol="0" anchor="ctr"/>
-          <a:lstStyle/>
-          <a:p>
-            <a:pPr indent="0" marL="0">
-              <a:buNone/>
-            </a:pPr>
-            <a:r>
-              <a:rPr lang="en-US" sz="1500" b="1" dirty="0">
-                <a:solidFill>
-                  <a:schemeClr val="tx1"/>
-                </a:solidFill>
-              </a:rPr>
-              <a:t>Answers from the live fleet</a:t>
-            </a:r>
-            <a:endParaRPr lang="en-US" sz="1500" dirty="0"/>
-          </a:p>
-        </p:txBody>
-      </p:sp>
-      <p:sp>
-        <p:nvSpPr>
-          <p:cNvPr id="10" name="Answers from the live fleet text"/>
-          <p:cNvSpPr txBox="1"/>
-          <p:nvPr/>
-        </p:nvSpPr>
-        <p:spPr>
-          <a:xfrm>
-            <a:off x="1097280" y="2313432"/>
-            <a:ext cx="2834640" cy="530352"/>
-          </a:xfrm>
-          <a:prstGeom prst="rect">
-            <a:avLst/>
-          </a:prstGeom>
-          <a:noFill/>
-          <a:ln/>
-        </p:spPr>
-        <p:txBody>
-          <a:bodyPr wrap="square" lIns="0" tIns="0" rIns="0" bIns="0" rtlCol="0" anchor="t"/>
-          <a:lstStyle/>
-          <a:p>
-            <a:pPr indent="0" marL="0">
-              <a:buNone/>
-            </a:pPr>
-            <a:r>
-              <a:rPr lang="en-US" sz="1250" dirty="0">
-                <a:solidFill>
-                  <a:schemeClr val="tx2"/>
-                </a:solidFill>
-              </a:rPr>
-              <a:t>Every car, price and seat count comes from MySQL, never from the model’s memory.</a:t>
-            </a:r>
-            <a:endParaRPr lang="en-US" sz="1250" dirty="0"/>
-          </a:p>
-        </p:txBody>
-      </p:sp>
-      <p:sp>
-        <p:nvSpPr>
-          <p:cNvPr id="11" name="One tap to the car badge"/>
-          <p:cNvSpPr/>
-          <p:nvPr/>
-        </p:nvSpPr>
-        <p:spPr>
-          <a:xfrm>
-            <a:off x="457200" y="2926080"/>
-            <a:ext cx="457200" cy="457200"/>
-          </a:xfrm>
-          <a:prstGeom prst="rect">
-            <a:avLst/>
-          </a:prstGeom>
-          <a:solidFill>
-            <a:schemeClr val="accent1"/>
-          </a:solidFill>
-          <a:ln/>
-        </p:spPr>
-      </p:sp>
-      <p:pic>
-        <p:nvPicPr>
-          <p:cNvPr id="12" name="One tap to the car icon" descr="preencoded.png">    </p:cNvPr>
+          <p:cNvPr id="4" name="Ask in plain words icon" descr="preencoded.png"/>
           <p:cNvPicPr>
             <a:picLocks noChangeAspect="1"/>
           </p:cNvPicPr>
@@ -2344,7 +1915,7 @@
         </p:blipFill>
         <p:spPr>
           <a:xfrm>
-            <a:off x="557784" y="3026664"/>
+            <a:off x="557784" y="1289304"/>
             <a:ext cx="256032" cy="256032"/>
           </a:xfrm>
           <a:prstGeom prst="rect">
@@ -2354,13 +1925,13 @@
       </p:pic>
       <p:sp>
         <p:nvSpPr>
-          <p:cNvPr id="13" name="One tap to the car heading"/>
+          <p:cNvPr id="5" name="Ask in plain words heading"/>
           <p:cNvSpPr txBox="1"/>
           <p:nvPr/>
         </p:nvSpPr>
         <p:spPr>
           <a:xfrm>
-            <a:off x="1097280" y="2889504"/>
+            <a:off x="1097280" y="1152144"/>
             <a:ext cx="2834640" cy="292608"/>
           </a:xfrm>
           <a:prstGeom prst="rect">
@@ -2373,7 +1944,7 @@
           <a:bodyPr wrap="square" lIns="0" tIns="0" rIns="0" bIns="0" rtlCol="0" anchor="ctr"/>
           <a:lstStyle/>
           <a:p>
-            <a:pPr indent="0" marL="0">
+            <a:pPr marL="0" indent="0">
               <a:buNone/>
             </a:pPr>
             <a:r>
@@ -2382,7 +1953,7 @@
                   <a:schemeClr val="tx1"/>
                 </a:solidFill>
               </a:rPr>
-              <a:t>One tap to the car</a:t>
+              <a:t>Ask in plain words</a:t>
             </a:r>
             <a:endParaRPr lang="en-US" sz="1500" dirty="0"/>
           </a:p>
@@ -2390,13 +1961,13 @@
       </p:sp>
       <p:sp>
         <p:nvSpPr>
-          <p:cNvPr id="14" name="One tap to the car text"/>
+          <p:cNvPr id="6" name="Ask in plain words text"/>
           <p:cNvSpPr txBox="1"/>
           <p:nvPr/>
         </p:nvSpPr>
         <p:spPr>
           <a:xfrm>
-            <a:off x="1097280" y="3182112"/>
+            <a:off x="1097280" y="1444752"/>
             <a:ext cx="2834640" cy="530352"/>
           </a:xfrm>
           <a:prstGeom prst="rect">
@@ -2409,7 +1980,7 @@
           <a:bodyPr wrap="square" lIns="0" tIns="0" rIns="0" bIns="0" rtlCol="0" anchor="t"/>
           <a:lstStyle/>
           <a:p>
-            <a:pPr indent="0" marL="0">
+            <a:pPr marL="0" indent="0">
               <a:buNone/>
             </a:pPr>
             <a:r>
@@ -2418,7 +1989,7 @@
                   <a:schemeClr val="tx2"/>
                 </a:solidFill>
               </a:rPr>
-              <a:t>Up to three suggested cars, each linking to its page to reserve.</a:t>
+              <a:t>Type “Five adults to Coorg, automatic” instead of setting filters.</a:t>
             </a:r>
             <a:endParaRPr lang="en-US" sz="1250" dirty="0"/>
           </a:p>
@@ -2426,13 +1997,13 @@
       </p:sp>
       <p:sp>
         <p:nvSpPr>
-          <p:cNvPr id="15" name="On every public page badge"/>
+          <p:cNvPr id="7" name="Answers from the live fleet badge"/>
           <p:cNvSpPr/>
           <p:nvPr/>
         </p:nvSpPr>
         <p:spPr>
           <a:xfrm>
-            <a:off x="457200" y="3794760"/>
+            <a:off x="457200" y="2057400"/>
             <a:ext cx="457200" cy="457200"/>
           </a:xfrm>
           <a:prstGeom prst="rect">
@@ -2443,10 +2014,17 @@
           </a:solidFill>
           <a:ln/>
         </p:spPr>
+        <p:txBody>
+          <a:bodyPr/>
+          <a:lstStyle/>
+          <a:p>
+            <a:endParaRPr lang="en-AE"/>
+          </a:p>
+        </p:txBody>
       </p:sp>
       <p:pic>
         <p:nvPicPr>
-          <p:cNvPr id="16" name="On every public page icon" descr="preencoded.png">    </p:cNvPr>
+          <p:cNvPr id="8" name="Answers from the live fleet icon" descr="preencoded.png"/>
           <p:cNvPicPr>
             <a:picLocks noChangeAspect="1"/>
           </p:cNvPicPr>
@@ -2460,7 +2038,7 @@
         </p:blipFill>
         <p:spPr>
           <a:xfrm>
-            <a:off x="557784" y="3895344"/>
+            <a:off x="557784" y="2157984"/>
             <a:ext cx="256032" cy="256032"/>
           </a:xfrm>
           <a:prstGeom prst="rect">
@@ -2470,13 +2048,13 @@
       </p:pic>
       <p:sp>
         <p:nvSpPr>
-          <p:cNvPr id="17" name="On every public page heading"/>
+          <p:cNvPr id="9" name="Answers from the live fleet heading"/>
           <p:cNvSpPr txBox="1"/>
           <p:nvPr/>
         </p:nvSpPr>
         <p:spPr>
           <a:xfrm>
-            <a:off x="1097280" y="3758184"/>
+            <a:off x="1097280" y="2020824"/>
             <a:ext cx="2834640" cy="292608"/>
           </a:xfrm>
           <a:prstGeom prst="rect">
@@ -2489,7 +2067,7 @@
           <a:bodyPr wrap="square" lIns="0" tIns="0" rIns="0" bIns="0" rtlCol="0" anchor="ctr"/>
           <a:lstStyle/>
           <a:p>
-            <a:pPr indent="0" marL="0">
+            <a:pPr marL="0" indent="0">
               <a:buNone/>
             </a:pPr>
             <a:r>
@@ -2498,7 +2076,7 @@
                   <a:schemeClr val="tx1"/>
                 </a:solidFill>
               </a:rPr>
-              <a:t>On every public page</a:t>
+              <a:t>Answers from the live fleet</a:t>
             </a:r>
             <a:endParaRPr lang="en-US" sz="1500" dirty="0"/>
           </a:p>
@@ -2506,13 +2084,13 @@
       </p:sp>
       <p:sp>
         <p:nvSpPr>
-          <p:cNvPr id="18" name="On every public page text"/>
+          <p:cNvPr id="10" name="Answers from the live fleet text"/>
           <p:cNvSpPr txBox="1"/>
           <p:nvPr/>
         </p:nvSpPr>
         <p:spPr>
           <a:xfrm>
-            <a:off x="1097280" y="4050792"/>
+            <a:off x="1097280" y="2313432"/>
             <a:ext cx="2834640" cy="530352"/>
           </a:xfrm>
           <a:prstGeom prst="rect">
@@ -2525,7 +2103,7 @@
           <a:bodyPr wrap="square" lIns="0" tIns="0" rIns="0" bIns="0" rtlCol="0" anchor="t"/>
           <a:lstStyle/>
           <a:p>
-            <a:pPr indent="0" marL="0">
+            <a:pPr marL="0" indent="0">
               <a:buNone/>
             </a:pPr>
             <a:r>
@@ -2534,15 +2112,42 @@
                   <a:schemeClr val="tx2"/>
                 </a:solidFill>
               </a:rPr>
-              <a:t>A “Which car?” button at the bottom right; the chat stays open across pages.</a:t>
+              <a:t>Every car, price and seat count comes from MySQL, never from the model’s memory.</a:t>
             </a:r>
             <a:endParaRPr lang="en-US" sz="1250" dirty="0"/>
+          </a:p>
+        </p:txBody>
+      </p:sp>
+      <p:sp>
+        <p:nvSpPr>
+          <p:cNvPr id="11" name="One tap to the car badge"/>
+          <p:cNvSpPr/>
+          <p:nvPr/>
+        </p:nvSpPr>
+        <p:spPr>
+          <a:xfrm>
+            <a:off x="457200" y="2926080"/>
+            <a:ext cx="457200" cy="457200"/>
+          </a:xfrm>
+          <a:prstGeom prst="rect">
+            <a:avLst/>
+          </a:prstGeom>
+          <a:solidFill>
+            <a:schemeClr val="accent1"/>
+          </a:solidFill>
+          <a:ln/>
+        </p:spPr>
+        <p:txBody>
+          <a:bodyPr/>
+          <a:lstStyle/>
+          <a:p>
+            <a:endParaRPr lang="en-AE"/>
           </a:p>
         </p:txBody>
       </p:sp>
       <p:pic>
         <p:nvPicPr>
-          <p:cNvPr id="19" name="The advisor open over the fleet page" descr="The advisor open over the fleet page">    </p:cNvPr>
+          <p:cNvPr id="12" name="One tap to the car icon" descr="preencoded.png"/>
           <p:cNvPicPr>
             <a:picLocks noChangeAspect="1"/>
           </p:cNvPicPr>
@@ -2556,6 +2161,225 @@
         </p:blipFill>
         <p:spPr>
           <a:xfrm>
+            <a:off x="557784" y="3026664"/>
+            <a:ext cx="256032" cy="256032"/>
+          </a:xfrm>
+          <a:prstGeom prst="rect">
+            <a:avLst/>
+          </a:prstGeom>
+        </p:spPr>
+      </p:pic>
+      <p:sp>
+        <p:nvSpPr>
+          <p:cNvPr id="13" name="One tap to the car heading"/>
+          <p:cNvSpPr txBox="1"/>
+          <p:nvPr/>
+        </p:nvSpPr>
+        <p:spPr>
+          <a:xfrm>
+            <a:off x="1097280" y="2889504"/>
+            <a:ext cx="2834640" cy="292608"/>
+          </a:xfrm>
+          <a:prstGeom prst="rect">
+            <a:avLst/>
+          </a:prstGeom>
+          <a:noFill/>
+          <a:ln/>
+        </p:spPr>
+        <p:txBody>
+          <a:bodyPr wrap="square" lIns="0" tIns="0" rIns="0" bIns="0" rtlCol="0" anchor="ctr"/>
+          <a:lstStyle/>
+          <a:p>
+            <a:pPr marL="0" indent="0">
+              <a:buNone/>
+            </a:pPr>
+            <a:r>
+              <a:rPr lang="en-US" sz="1500" b="1" dirty="0">
+                <a:solidFill>
+                  <a:schemeClr val="tx1"/>
+                </a:solidFill>
+              </a:rPr>
+              <a:t>One tap to the car</a:t>
+            </a:r>
+            <a:endParaRPr lang="en-US" sz="1500" dirty="0"/>
+          </a:p>
+        </p:txBody>
+      </p:sp>
+      <p:sp>
+        <p:nvSpPr>
+          <p:cNvPr id="14" name="One tap to the car text"/>
+          <p:cNvSpPr txBox="1"/>
+          <p:nvPr/>
+        </p:nvSpPr>
+        <p:spPr>
+          <a:xfrm>
+            <a:off x="1097280" y="3182112"/>
+            <a:ext cx="2834640" cy="530352"/>
+          </a:xfrm>
+          <a:prstGeom prst="rect">
+            <a:avLst/>
+          </a:prstGeom>
+          <a:noFill/>
+          <a:ln/>
+        </p:spPr>
+        <p:txBody>
+          <a:bodyPr wrap="square" lIns="0" tIns="0" rIns="0" bIns="0" rtlCol="0" anchor="t"/>
+          <a:lstStyle/>
+          <a:p>
+            <a:pPr marL="0" indent="0">
+              <a:buNone/>
+            </a:pPr>
+            <a:r>
+              <a:rPr lang="en-US" sz="1250" dirty="0">
+                <a:solidFill>
+                  <a:schemeClr val="tx2"/>
+                </a:solidFill>
+              </a:rPr>
+              <a:t>Up to three suggested cars, each linking to its page to reserve.</a:t>
+            </a:r>
+            <a:endParaRPr lang="en-US" sz="1250" dirty="0"/>
+          </a:p>
+        </p:txBody>
+      </p:sp>
+      <p:sp>
+        <p:nvSpPr>
+          <p:cNvPr id="15" name="On every public page badge"/>
+          <p:cNvSpPr/>
+          <p:nvPr/>
+        </p:nvSpPr>
+        <p:spPr>
+          <a:xfrm>
+            <a:off x="457200" y="3794760"/>
+            <a:ext cx="457200" cy="457200"/>
+          </a:xfrm>
+          <a:prstGeom prst="rect">
+            <a:avLst/>
+          </a:prstGeom>
+          <a:solidFill>
+            <a:schemeClr val="accent1"/>
+          </a:solidFill>
+          <a:ln/>
+        </p:spPr>
+        <p:txBody>
+          <a:bodyPr/>
+          <a:lstStyle/>
+          <a:p>
+            <a:endParaRPr lang="en-AE"/>
+          </a:p>
+        </p:txBody>
+      </p:sp>
+      <p:pic>
+        <p:nvPicPr>
+          <p:cNvPr id="16" name="On every public page icon" descr="preencoded.png"/>
+          <p:cNvPicPr>
+            <a:picLocks noChangeAspect="1"/>
+          </p:cNvPicPr>
+          <p:nvPr/>
+        </p:nvPicPr>
+        <p:blipFill>
+          <a:blip r:embed="rId6"/>
+          <a:stretch>
+            <a:fillRect/>
+          </a:stretch>
+        </p:blipFill>
+        <p:spPr>
+          <a:xfrm>
+            <a:off x="557784" y="3895344"/>
+            <a:ext cx="256032" cy="256032"/>
+          </a:xfrm>
+          <a:prstGeom prst="rect">
+            <a:avLst/>
+          </a:prstGeom>
+        </p:spPr>
+      </p:pic>
+      <p:sp>
+        <p:nvSpPr>
+          <p:cNvPr id="17" name="On every public page heading"/>
+          <p:cNvSpPr txBox="1"/>
+          <p:nvPr/>
+        </p:nvSpPr>
+        <p:spPr>
+          <a:xfrm>
+            <a:off x="1097280" y="3758184"/>
+            <a:ext cx="2834640" cy="292608"/>
+          </a:xfrm>
+          <a:prstGeom prst="rect">
+            <a:avLst/>
+          </a:prstGeom>
+          <a:noFill/>
+          <a:ln/>
+        </p:spPr>
+        <p:txBody>
+          <a:bodyPr wrap="square" lIns="0" tIns="0" rIns="0" bIns="0" rtlCol="0" anchor="ctr"/>
+          <a:lstStyle/>
+          <a:p>
+            <a:pPr marL="0" indent="0">
+              <a:buNone/>
+            </a:pPr>
+            <a:r>
+              <a:rPr lang="en-US" sz="1500" b="1" dirty="0">
+                <a:solidFill>
+                  <a:schemeClr val="tx1"/>
+                </a:solidFill>
+              </a:rPr>
+              <a:t>On every public page</a:t>
+            </a:r>
+            <a:endParaRPr lang="en-US" sz="1500" dirty="0"/>
+          </a:p>
+        </p:txBody>
+      </p:sp>
+      <p:sp>
+        <p:nvSpPr>
+          <p:cNvPr id="18" name="On every public page text"/>
+          <p:cNvSpPr txBox="1"/>
+          <p:nvPr/>
+        </p:nvSpPr>
+        <p:spPr>
+          <a:xfrm>
+            <a:off x="1097280" y="4050792"/>
+            <a:ext cx="2834640" cy="530352"/>
+          </a:xfrm>
+          <a:prstGeom prst="rect">
+            <a:avLst/>
+          </a:prstGeom>
+          <a:noFill/>
+          <a:ln/>
+        </p:spPr>
+        <p:txBody>
+          <a:bodyPr wrap="square" lIns="0" tIns="0" rIns="0" bIns="0" rtlCol="0" anchor="t"/>
+          <a:lstStyle/>
+          <a:p>
+            <a:pPr marL="0" indent="0">
+              <a:buNone/>
+            </a:pPr>
+            <a:r>
+              <a:rPr lang="en-US" sz="1250" dirty="0">
+                <a:solidFill>
+                  <a:schemeClr val="tx2"/>
+                </a:solidFill>
+              </a:rPr>
+              <a:t>A “Which car?” button at the bottom right; the chat stays open across pages.</a:t>
+            </a:r>
+            <a:endParaRPr lang="en-US" sz="1250" dirty="0"/>
+          </a:p>
+        </p:txBody>
+      </p:sp>
+      <p:pic>
+        <p:nvPicPr>
+          <p:cNvPr id="19" name="The advisor open over the fleet page" descr="The advisor open over the fleet page"/>
+          <p:cNvPicPr>
+            <a:picLocks noChangeAspect="1"/>
+          </p:cNvPicPr>
+          <p:nvPr/>
+        </p:nvPicPr>
+        <p:blipFill>
+          <a:blip r:embed="rId7"/>
+          <a:stretch>
+            <a:fillRect/>
+          </a:stretch>
+        </p:blipFill>
+        <p:spPr>
+          <a:xfrm>
             <a:off x="4206240" y="1188720"/>
             <a:ext cx="4480560" cy="2798064"/>
           </a:xfrm>
@@ -2563,7 +2387,7 @@
             <a:avLst/>
           </a:prstGeom>
           <a:effectLst>
-            <a:outerShdw sx="100000" sy="100000" kx="0" ky="0" algn="bl" rotWithShape="0" blurRad="127000" dist="38100" dir="5400000">
+            <a:outerShdw blurRad="127000" dist="38100" dir="5400000" algn="bl" rotWithShape="0">
               <a:srgbClr val="1A1A1A">
                 <a:alpha val="28000"/>
               </a:srgbClr>
@@ -2592,7 +2416,7 @@
           <a:bodyPr wrap="square" lIns="0" tIns="0" rIns="0" bIns="0" rtlCol="0" anchor="ctr"/>
           <a:lstStyle/>
           <a:p>
-            <a:pPr indent="0" marL="0">
+            <a:pPr marL="0" indent="0">
               <a:buNone/>
             </a:pPr>
             <a:r>
@@ -2627,7 +2451,7 @@
           </a:prstGeom>
           <a:extLst>
             <a:ext uri="{C572A759-6A51-4108-AA02-DFA0A04FC94B}">
-              <ma14:wrappingTextBoxFlag xmlns:ma14="http://schemas.microsoft.com/office/mac/drawingml/2011/main" val="0"/>
+              <ma14:wrappingTextBoxFlag xmlns:ma14="http://schemas.microsoft.com/office/mac/drawingml/2011/main" xmlns="" val="0"/>
             </a:ext>
           </a:extLst>
         </p:spPr>
@@ -2645,7 +2469,7 @@
           <a:p>
             <a:pPr algn="r"/>
             <a:fld id="{F7021451-1387-4CA6-816F-3879F97B5CBC}" type="slidenum">
-              <a:rPr b="0" lang="en-US"/>
+              <a:rPr lang="en-US" b="0"/>
               <a:t>2</a:t>
             </a:fld>
             <a:endParaRPr lang="en-US"/>
@@ -2680,9 +2504,11 @@
       <p:sp>
         <p:nvSpPr>
           <p:cNvPr id="2" name="Text 0"/>
-          <p:cNvSpPr/>
+          <p:cNvSpPr>
+            <a:spLocks noGrp="1"/>
+          </p:cNvSpPr>
           <p:nvPr>
-            <p:ph idx="100" type="title" hasCustomPrompt="1"/>
+            <p:ph type="title" idx="100" hasCustomPrompt="1"/>
           </p:nvPr>
         </p:nvSpPr>
         <p:spPr>
@@ -2700,7 +2526,7 @@
           <a:bodyPr wrap="square" lIns="0" tIns="0" rIns="0" bIns="0" rtlCol="0" anchor="ctr"/>
           <a:lstStyle/>
           <a:p>
-            <a:pPr algn="l" indent="0" marL="0">
+            <a:pPr marL="0" indent="0" algn="l">
               <a:buNone/>
             </a:pPr>
             <a:r>
@@ -2742,6 +2568,13 @@
             <a:prstDash val="solid"/>
           </a:ln>
         </p:spPr>
+        <p:txBody>
+          <a:bodyPr/>
+          <a:lstStyle/>
+          <a:p>
+            <a:endParaRPr lang="en-AE"/>
+          </a:p>
+        </p:txBody>
       </p:sp>
       <p:sp>
         <p:nvSpPr>
@@ -2764,7 +2597,7 @@
           <a:bodyPr wrap="square" lIns="0" tIns="0" rIns="0" bIns="0" rtlCol="0" anchor="t"/>
           <a:lstStyle/>
           <a:p>
-            <a:pPr indent="0" marL="0">
+            <a:pPr marL="0" indent="0">
               <a:buNone/>
             </a:pPr>
             <a:r>
@@ -2778,7 +2611,7 @@
             <a:endParaRPr lang="en-US" sz="1400" dirty="0"/>
           </a:p>
           <a:p>
-            <a:pPr indent="0" marL="0">
+            <a:pPr marL="0" indent="0">
               <a:buNone/>
             </a:pPr>
             <a:r>
@@ -2817,6 +2650,13 @@
             <a:prstDash val="solid"/>
           </a:ln>
         </p:spPr>
+        <p:txBody>
+          <a:bodyPr/>
+          <a:lstStyle/>
+          <a:p>
+            <a:endParaRPr lang="en-AE"/>
+          </a:p>
+        </p:txBody>
       </p:sp>
       <p:sp>
         <p:nvSpPr>
@@ -2839,7 +2679,7 @@
           <a:bodyPr wrap="square" lIns="0" tIns="0" rIns="0" bIns="0" rtlCol="0" anchor="t"/>
           <a:lstStyle/>
           <a:p>
-            <a:pPr indent="0" marL="0">
+            <a:pPr marL="0" indent="0">
               <a:buNone/>
             </a:pPr>
             <a:r>
@@ -2853,7 +2693,7 @@
             <a:endParaRPr lang="en-US" sz="1400" dirty="0"/>
           </a:p>
           <a:p>
-            <a:pPr indent="0" marL="0">
+            <a:pPr marL="0" indent="0">
               <a:buNone/>
             </a:pPr>
             <a:r>
@@ -2892,6 +2732,13 @@
             <a:prstDash val="solid"/>
           </a:ln>
         </p:spPr>
+        <p:txBody>
+          <a:bodyPr/>
+          <a:lstStyle/>
+          <a:p>
+            <a:endParaRPr lang="en-AE"/>
+          </a:p>
+        </p:txBody>
       </p:sp>
       <p:sp>
         <p:nvSpPr>
@@ -2914,7 +2761,7 @@
           <a:bodyPr wrap="square" lIns="0" tIns="0" rIns="0" bIns="0" rtlCol="0" anchor="t"/>
           <a:lstStyle/>
           <a:p>
-            <a:pPr indent="0" marL="0">
+            <a:pPr marL="0" indent="0">
               <a:buNone/>
             </a:pPr>
             <a:r>
@@ -2928,7 +2775,7 @@
             <a:endParaRPr lang="en-US" sz="1400" dirty="0"/>
           </a:p>
           <a:p>
-            <a:pPr indent="0" marL="0">
+            <a:pPr marL="0" indent="0">
               <a:buNone/>
             </a:pPr>
             <a:r>
@@ -2967,6 +2814,13 @@
             <a:prstDash val="solid"/>
           </a:ln>
         </p:spPr>
+        <p:txBody>
+          <a:bodyPr/>
+          <a:lstStyle/>
+          <a:p>
+            <a:endParaRPr lang="en-AE"/>
+          </a:p>
+        </p:txBody>
       </p:sp>
       <p:sp>
         <p:nvSpPr>
@@ -2989,7 +2843,7 @@
           <a:bodyPr wrap="square" lIns="0" tIns="0" rIns="0" bIns="0" rtlCol="0" anchor="t"/>
           <a:lstStyle/>
           <a:p>
-            <a:pPr indent="0" marL="0">
+            <a:pPr marL="0" indent="0">
               <a:buNone/>
             </a:pPr>
             <a:r>
@@ -3003,7 +2857,7 @@
             <a:endParaRPr lang="en-US" sz="1400" dirty="0"/>
           </a:p>
           <a:p>
-            <a:pPr indent="0" marL="0">
+            <a:pPr marL="0" indent="0">
               <a:buNone/>
             </a:pPr>
             <a:r>
@@ -3042,6 +2896,13 @@
             <a:tailEnd type="triangle"/>
           </a:ln>
         </p:spPr>
+        <p:txBody>
+          <a:bodyPr/>
+          <a:lstStyle/>
+          <a:p>
+            <a:endParaRPr lang="en-AE"/>
+          </a:p>
+        </p:txBody>
       </p:sp>
       <p:sp>
         <p:nvSpPr>
@@ -3067,6 +2928,13 @@
             <a:tailEnd type="triangle"/>
           </a:ln>
         </p:spPr>
+        <p:txBody>
+          <a:bodyPr/>
+          <a:lstStyle/>
+          <a:p>
+            <a:endParaRPr lang="en-AE"/>
+          </a:p>
+        </p:txBody>
       </p:sp>
       <p:sp>
         <p:nvSpPr>
@@ -3092,6 +2960,13 @@
             <a:tailEnd type="triangle"/>
           </a:ln>
         </p:spPr>
+        <p:txBody>
+          <a:bodyPr/>
+          <a:lstStyle/>
+          <a:p>
+            <a:endParaRPr lang="en-AE"/>
+          </a:p>
+        </p:txBody>
       </p:sp>
       <p:sp>
         <p:nvSpPr>
@@ -3112,6 +2987,13 @@
           </a:solidFill>
           <a:ln/>
         </p:spPr>
+        <p:txBody>
+          <a:bodyPr/>
+          <a:lstStyle/>
+          <a:p>
+            <a:endParaRPr lang="en-AE"/>
+          </a:p>
+        </p:txBody>
       </p:sp>
       <p:sp>
         <p:nvSpPr>
@@ -3134,7 +3016,7 @@
           <a:bodyPr wrap="square" lIns="0" tIns="0" rIns="0" bIns="0" rtlCol="0" anchor="ctr"/>
           <a:lstStyle/>
           <a:p>
-            <a:pPr algn="ctr" indent="0" marL="0">
+            <a:pPr marL="0" indent="0" algn="ctr">
               <a:buNone/>
             </a:pPr>
             <a:r>
@@ -3170,7 +3052,7 @@
           <a:bodyPr wrap="square" lIns="0" tIns="0" rIns="0" bIns="0" rtlCol="0" anchor="ctr"/>
           <a:lstStyle/>
           <a:p>
-            <a:pPr indent="0" marL="0">
+            <a:pPr marL="0" indent="0">
               <a:buNone/>
             </a:pPr>
             <a:r>
@@ -3204,6 +3086,13 @@
           </a:solidFill>
           <a:ln/>
         </p:spPr>
+        <p:txBody>
+          <a:bodyPr/>
+          <a:lstStyle/>
+          <a:p>
+            <a:endParaRPr lang="en-AE"/>
+          </a:p>
+        </p:txBody>
       </p:sp>
       <p:sp>
         <p:nvSpPr>
@@ -3226,7 +3115,7 @@
           <a:bodyPr wrap="square" lIns="0" tIns="0" rIns="0" bIns="0" rtlCol="0" anchor="ctr"/>
           <a:lstStyle/>
           <a:p>
-            <a:pPr algn="ctr" indent="0" marL="0">
+            <a:pPr marL="0" indent="0" algn="ctr">
               <a:buNone/>
             </a:pPr>
             <a:r>
@@ -3262,7 +3151,7 @@
           <a:bodyPr wrap="square" lIns="0" tIns="0" rIns="0" bIns="0" rtlCol="0" anchor="ctr"/>
           <a:lstStyle/>
           <a:p>
-            <a:pPr indent="0" marL="0">
+            <a:pPr marL="0" indent="0">
               <a:buNone/>
             </a:pPr>
             <a:r>
@@ -3296,6 +3185,13 @@
           </a:solidFill>
           <a:ln/>
         </p:spPr>
+        <p:txBody>
+          <a:bodyPr/>
+          <a:lstStyle/>
+          <a:p>
+            <a:endParaRPr lang="en-AE"/>
+          </a:p>
+        </p:txBody>
       </p:sp>
       <p:sp>
         <p:nvSpPr>
@@ -3318,7 +3214,7 @@
           <a:bodyPr wrap="square" lIns="0" tIns="0" rIns="0" bIns="0" rtlCol="0" anchor="ctr"/>
           <a:lstStyle/>
           <a:p>
-            <a:pPr algn="ctr" indent="0" marL="0">
+            <a:pPr marL="0" indent="0" algn="ctr">
               <a:buNone/>
             </a:pPr>
             <a:r>
@@ -3354,7 +3250,7 @@
           <a:bodyPr wrap="square" lIns="0" tIns="0" rIns="0" bIns="0" rtlCol="0" anchor="ctr"/>
           <a:lstStyle/>
           <a:p>
-            <a:pPr indent="0" marL="0">
+            <a:pPr marL="0" indent="0">
               <a:buNone/>
             </a:pPr>
             <a:r>
@@ -3388,6 +3284,13 @@
           </a:solidFill>
           <a:ln/>
         </p:spPr>
+        <p:txBody>
+          <a:bodyPr/>
+          <a:lstStyle/>
+          <a:p>
+            <a:endParaRPr lang="en-AE"/>
+          </a:p>
+        </p:txBody>
       </p:sp>
       <p:sp>
         <p:nvSpPr>
@@ -3410,7 +3313,7 @@
           <a:bodyPr wrap="square" lIns="0" tIns="0" rIns="0" bIns="0" rtlCol="0" anchor="ctr"/>
           <a:lstStyle/>
           <a:p>
-            <a:pPr algn="ctr" indent="0" marL="0">
+            <a:pPr marL="0" indent="0" algn="ctr">
               <a:buNone/>
             </a:pPr>
             <a:r>
@@ -3446,7 +3349,7 @@
           <a:bodyPr wrap="square" lIns="0" tIns="0" rIns="0" bIns="0" rtlCol="0" anchor="ctr"/>
           <a:lstStyle/>
           <a:p>
-            <a:pPr indent="0" marL="0">
+            <a:pPr marL="0" indent="0">
               <a:buNone/>
             </a:pPr>
             <a:r>
@@ -3480,6 +3383,13 @@
           </a:solidFill>
           <a:ln/>
         </p:spPr>
+        <p:txBody>
+          <a:bodyPr/>
+          <a:lstStyle/>
+          <a:p>
+            <a:endParaRPr lang="en-AE"/>
+          </a:p>
+        </p:txBody>
       </p:sp>
       <p:sp>
         <p:nvSpPr>
@@ -3502,7 +3412,7 @@
           <a:bodyPr wrap="square" lIns="0" tIns="0" rIns="0" bIns="0" rtlCol="0" anchor="ctr"/>
           <a:lstStyle/>
           <a:p>
-            <a:pPr algn="ctr" indent="0" marL="0">
+            <a:pPr marL="0" indent="0" algn="ctr">
               <a:buNone/>
             </a:pPr>
             <a:r>
@@ -3538,7 +3448,7 @@
           <a:bodyPr wrap="square" lIns="0" tIns="0" rIns="0" bIns="0" rtlCol="0" anchor="ctr"/>
           <a:lstStyle/>
           <a:p>
-            <a:pPr indent="0" marL="0">
+            <a:pPr marL="0" indent="0">
               <a:buNone/>
             </a:pPr>
             <a:r>
@@ -3572,6 +3482,13 @@
           </a:solidFill>
           <a:ln/>
         </p:spPr>
+        <p:txBody>
+          <a:bodyPr/>
+          <a:lstStyle/>
+          <a:p>
+            <a:endParaRPr lang="en-AE"/>
+          </a:p>
+        </p:txBody>
       </p:sp>
       <p:sp>
         <p:nvSpPr>
@@ -3594,7 +3511,7 @@
           <a:bodyPr wrap="square" lIns="0" tIns="0" rIns="0" bIns="0" rtlCol="0" anchor="ctr"/>
           <a:lstStyle/>
           <a:p>
-            <a:pPr algn="ctr" indent="0" marL="0">
+            <a:pPr marL="0" indent="0" algn="ctr">
               <a:buNone/>
             </a:pPr>
             <a:r>
@@ -3630,7 +3547,7 @@
           <a:bodyPr wrap="square" lIns="0" tIns="0" rIns="0" bIns="0" rtlCol="0" anchor="ctr"/>
           <a:lstStyle/>
           <a:p>
-            <a:pPr indent="0" marL="0">
+            <a:pPr marL="0" indent="0">
               <a:buNone/>
             </a:pPr>
             <a:r>
@@ -3647,7 +3564,7 @@
       </p:sp>
       <p:sp>
         <p:nvSpPr>
-          <p:cNvPr id="25" name="Slide Number Placeholder 0"/>
+          <p:cNvPr id="32" name="Slide Number Placeholder 0"/>
           <p:cNvSpPr>
             <a:spLocks noGrp="1"/>
           </p:cNvSpPr>
@@ -3665,7 +3582,7 @@
           </a:prstGeom>
           <a:extLst>
             <a:ext uri="{C572A759-6A51-4108-AA02-DFA0A04FC94B}">
-              <ma14:wrappingTextBoxFlag xmlns:ma14="http://schemas.microsoft.com/office/mac/drawingml/2011/main" val="0"/>
+              <ma14:wrappingTextBoxFlag xmlns:ma14="http://schemas.microsoft.com/office/mac/drawingml/2011/main" xmlns="" val="0"/>
             </a:ext>
           </a:extLst>
         </p:spPr>
@@ -3683,7 +3600,7 @@
           <a:p>
             <a:pPr algn="r"/>
             <a:fld id="{F7021451-1387-4CA6-816F-3879F97B5CBC}" type="slidenum">
-              <a:rPr b="0" lang="en-US"/>
+              <a:rPr lang="en-US" b="0"/>
               <a:t>3</a:t>
             </a:fld>
             <a:endParaRPr lang="en-US"/>
@@ -3718,9 +3635,11 @@
       <p:sp>
         <p:nvSpPr>
           <p:cNvPr id="2" name="Text 0"/>
-          <p:cNvSpPr/>
+          <p:cNvSpPr>
+            <a:spLocks noGrp="1"/>
+          </p:cNvSpPr>
           <p:nvPr>
-            <p:ph idx="100" type="title" hasCustomPrompt="1"/>
+            <p:ph type="title" idx="100" hasCustomPrompt="1"/>
           </p:nvPr>
         </p:nvSpPr>
         <p:spPr>
@@ -3738,7 +3657,7 @@
           <a:bodyPr wrap="square" lIns="0" tIns="0" rIns="0" bIns="0" rtlCol="0" anchor="ctr"/>
           <a:lstStyle/>
           <a:p>
-            <a:pPr algn="l" indent="0" marL="0">
+            <a:pPr marL="0" indent="0" algn="l">
               <a:buNone/>
             </a:pPr>
             <a:r>
@@ -3777,7 +3696,7 @@
           <a:bodyPr wrap="square" lIns="0" tIns="0" rIns="0" bIns="0" rtlCol="0" anchor="ctr"/>
           <a:lstStyle/>
           <a:p>
-            <a:pPr indent="0" marL="0">
+            <a:pPr marL="0" indent="0">
               <a:buNone/>
             </a:pPr>
             <a:r>
@@ -3813,7 +3732,7 @@
           <a:bodyPr wrap="square" lIns="0" tIns="0" rIns="0" bIns="0" rtlCol="0" anchor="t"/>
           <a:lstStyle/>
           <a:p>
-            <a:pPr indent="0" marL="0">
+            <a:pPr marL="0" indent="0">
               <a:buNone/>
             </a:pPr>
             <a:r>
@@ -3849,7 +3768,7 @@
           <a:bodyPr wrap="square" lIns="0" tIns="0" rIns="0" bIns="0" rtlCol="0" anchor="ctr"/>
           <a:lstStyle/>
           <a:p>
-            <a:pPr indent="0" marL="0">
+            <a:pPr marL="0" indent="0">
               <a:buNone/>
             </a:pPr>
             <a:r>
@@ -3885,7 +3804,7 @@
           <a:bodyPr wrap="square" lIns="0" tIns="0" rIns="0" bIns="0" rtlCol="0" anchor="t"/>
           <a:lstStyle/>
           <a:p>
-            <a:pPr indent="0" marL="0">
+            <a:pPr marL="0" indent="0">
               <a:buNone/>
             </a:pPr>
             <a:r>
@@ -3921,7 +3840,7 @@
           <a:bodyPr wrap="square" lIns="0" tIns="0" rIns="0" bIns="0" rtlCol="0" anchor="ctr"/>
           <a:lstStyle/>
           <a:p>
-            <a:pPr indent="0" marL="0">
+            <a:pPr marL="0" indent="0">
               <a:buNone/>
             </a:pPr>
             <a:r>
@@ -3957,7 +3876,7 @@
           <a:bodyPr wrap="square" lIns="0" tIns="0" rIns="0" bIns="0" rtlCol="0" anchor="t"/>
           <a:lstStyle/>
           <a:p>
-            <a:pPr indent="0" marL="0">
+            <a:pPr marL="0" indent="0">
               <a:buNone/>
             </a:pPr>
             <a:r>
@@ -3991,6 +3910,13 @@
           </a:solidFill>
           <a:ln/>
         </p:spPr>
+        <p:txBody>
+          <a:bodyPr/>
+          <a:lstStyle/>
+          <a:p>
+            <a:endParaRPr lang="en-AE"/>
+          </a:p>
+        </p:txBody>
       </p:sp>
       <p:sp>
         <p:nvSpPr>
@@ -4013,7 +3939,7 @@
           <a:bodyPr wrap="square" lIns="0" tIns="0" rIns="0" bIns="0" rtlCol="0" anchor="ctr"/>
           <a:lstStyle/>
           <a:p>
-            <a:pPr indent="0" marL="0">
+            <a:pPr marL="0" indent="0">
               <a:buNone/>
             </a:pPr>
             <a:r>
@@ -4049,7 +3975,7 @@
           <a:bodyPr wrap="square" lIns="0" tIns="0" rIns="0" bIns="0" rtlCol="0" anchor="t"/>
           <a:lstStyle/>
           <a:p>
-            <a:pPr indent="0" marL="0">
+            <a:pPr marL="0" indent="0">
               <a:buNone/>
             </a:pPr>
             <a:r>
@@ -4066,7 +3992,7 @@
             <a:endParaRPr lang="en-US" sz="1050" dirty="0"/>
           </a:p>
           <a:p>
-            <a:pPr indent="0" marL="0">
+            <a:pPr marL="0" indent="0">
               <a:buNone/>
             </a:pPr>
             <a:r>
@@ -4083,7 +4009,7 @@
             <a:endParaRPr lang="en-US" sz="1050" dirty="0"/>
           </a:p>
           <a:p>
-            <a:pPr indent="0" marL="0">
+            <a:pPr marL="0" indent="0">
               <a:buNone/>
             </a:pPr>
             <a:r>
@@ -4100,7 +4026,7 @@
             <a:endParaRPr lang="en-US" sz="1050" dirty="0"/>
           </a:p>
           <a:p>
-            <a:pPr indent="0" marL="0">
+            <a:pPr marL="0" indent="0">
               <a:buNone/>
             </a:pPr>
             <a:r>
@@ -4117,7 +4043,7 @@
             <a:endParaRPr lang="en-US" sz="1050" dirty="0"/>
           </a:p>
           <a:p>
-            <a:pPr indent="0" marL="0">
+            <a:pPr marL="0" indent="0">
               <a:buNone/>
             </a:pPr>
             <a:r>
@@ -4134,7 +4060,7 @@
             <a:endParaRPr lang="en-US" sz="1050" dirty="0"/>
           </a:p>
           <a:p>
-            <a:pPr indent="0" marL="0">
+            <a:pPr marL="0" indent="0">
               <a:buNone/>
             </a:pPr>
             <a:r>
@@ -4151,7 +4077,7 @@
             <a:endParaRPr lang="en-US" sz="1050" dirty="0"/>
           </a:p>
           <a:p>
-            <a:pPr indent="0" marL="0">
+            <a:pPr marL="0" indent="0">
               <a:buNone/>
             </a:pPr>
             <a:r>
@@ -4168,7 +4094,7 @@
             <a:endParaRPr lang="en-US" sz="1050" dirty="0"/>
           </a:p>
           <a:p>
-            <a:pPr indent="0" marL="0">
+            <a:pPr marL="0" indent="0">
               <a:buNone/>
             </a:pPr>
             <a:r>
@@ -4185,7 +4111,7 @@
             <a:endParaRPr lang="en-US" sz="1050" dirty="0"/>
           </a:p>
           <a:p>
-            <a:pPr indent="0" marL="0">
+            <a:pPr marL="0" indent="0">
               <a:buNone/>
             </a:pPr>
             <a:r>
@@ -4202,7 +4128,7 @@
             <a:endParaRPr lang="en-US" sz="1050" dirty="0"/>
           </a:p>
           <a:p>
-            <a:pPr indent="0" marL="0">
+            <a:pPr marL="0" indent="0">
               <a:buNone/>
             </a:pPr>
             <a:r>
@@ -4219,7 +4145,7 @@
             <a:endParaRPr lang="en-US" sz="1050" dirty="0"/>
           </a:p>
           <a:p>
-            <a:pPr indent="0" marL="0">
+            <a:pPr marL="0" indent="0">
               <a:buNone/>
             </a:pPr>
             <a:r>
@@ -4236,7 +4162,7 @@
             <a:endParaRPr lang="en-US" sz="1050" dirty="0"/>
           </a:p>
           <a:p>
-            <a:pPr indent="0" marL="0">
+            <a:pPr marL="0" indent="0">
               <a:buNone/>
             </a:pPr>
             <a:r>
@@ -4253,13 +4179,13 @@
             <a:endParaRPr lang="en-US" sz="1050" dirty="0"/>
           </a:p>
           <a:p>
-            <a:pPr indent="0" marL="0">
+            <a:pPr marL="0" indent="0">
               <a:buNone/>
             </a:pPr>
             <a:endParaRPr lang="en-US" sz="1050" dirty="0"/>
           </a:p>
           <a:p>
-            <a:pPr indent="0" marL="0">
+            <a:pPr marL="0" indent="0">
               <a:buNone/>
             </a:pPr>
             <a:r>
@@ -4276,7 +4202,7 @@
             <a:endParaRPr lang="en-US" sz="1050" dirty="0"/>
           </a:p>
           <a:p>
-            <a:pPr indent="0" marL="0">
+            <a:pPr marL="0" indent="0">
               <a:buNone/>
             </a:pPr>
             <a:r>
@@ -4293,7 +4219,7 @@
             <a:endParaRPr lang="en-US" sz="1050" dirty="0"/>
           </a:p>
           <a:p>
-            <a:pPr indent="0" marL="0">
+            <a:pPr marL="0" indent="0">
               <a:buNone/>
             </a:pPr>
             <a:r>
@@ -4331,7 +4257,7 @@
           </a:prstGeom>
           <a:extLst>
             <a:ext uri="{C572A759-6A51-4108-AA02-DFA0A04FC94B}">
-              <ma14:wrappingTextBoxFlag xmlns:ma14="http://schemas.microsoft.com/office/mac/drawingml/2011/main" val="0"/>
+              <ma14:wrappingTextBoxFlag xmlns:ma14="http://schemas.microsoft.com/office/mac/drawingml/2011/main" xmlns="" val="0"/>
             </a:ext>
           </a:extLst>
         </p:spPr>
@@ -4349,7 +4275,7 @@
           <a:p>
             <a:pPr algn="r"/>
             <a:fld id="{F7021451-1387-4CA6-816F-3879F97B5CBC}" type="slidenum">
-              <a:rPr b="0" lang="en-US"/>
+              <a:rPr lang="en-US" b="0"/>
               <a:t>4</a:t>
             </a:fld>
             <a:endParaRPr lang="en-US"/>
@@ -4384,9 +4310,11 @@
       <p:sp>
         <p:nvSpPr>
           <p:cNvPr id="2" name="Text 0"/>
-          <p:cNvSpPr/>
+          <p:cNvSpPr>
+            <a:spLocks noGrp="1"/>
+          </p:cNvSpPr>
           <p:nvPr>
-            <p:ph idx="100" type="title" hasCustomPrompt="1"/>
+            <p:ph type="title" idx="100" hasCustomPrompt="1"/>
           </p:nvPr>
         </p:nvSpPr>
         <p:spPr>
@@ -4404,7 +4332,7 @@
           <a:bodyPr wrap="square" lIns="0" tIns="0" rIns="0" bIns="0" rtlCol="0" anchor="ctr"/>
           <a:lstStyle/>
           <a:p>
-            <a:pPr algn="l" indent="0" marL="0">
+            <a:pPr marL="0" indent="0" algn="l">
               <a:buNone/>
             </a:pPr>
             <a:r>
@@ -4441,6 +4369,13 @@
           </a:solidFill>
           <a:ln/>
         </p:spPr>
+        <p:txBody>
+          <a:bodyPr/>
+          <a:lstStyle/>
+          <a:p>
+            <a:endParaRPr lang="en-AE"/>
+          </a:p>
+        </p:txBody>
       </p:sp>
       <p:sp>
         <p:nvSpPr>
@@ -4463,7 +4398,7 @@
           <a:bodyPr wrap="square" lIns="0" tIns="0" rIns="0" bIns="0" rtlCol="0" anchor="ctr"/>
           <a:lstStyle/>
           <a:p>
-            <a:pPr indent="0" marL="0">
+            <a:pPr marL="0" indent="0">
               <a:buNone/>
             </a:pPr>
             <a:r>
@@ -4499,7 +4434,7 @@
           <a:bodyPr wrap="square" lIns="0" tIns="0" rIns="0" bIns="0" rtlCol="0" anchor="t"/>
           <a:lstStyle/>
           <a:p>
-            <a:pPr indent="0" marL="0">
+            <a:pPr marL="0" indent="0">
               <a:buNone/>
             </a:pPr>
             <a:r>
@@ -4516,7 +4451,7 @@
             <a:endParaRPr lang="en-US" sz="1000" dirty="0"/>
           </a:p>
           <a:p>
-            <a:pPr indent="0" marL="0">
+            <a:pPr marL="0" indent="0">
               <a:buNone/>
             </a:pPr>
             <a:r>
@@ -4533,7 +4468,7 @@
             <a:endParaRPr lang="en-US" sz="1000" dirty="0"/>
           </a:p>
           <a:p>
-            <a:pPr indent="0" marL="0">
+            <a:pPr marL="0" indent="0">
               <a:buNone/>
             </a:pPr>
             <a:r>
@@ -4550,7 +4485,7 @@
             <a:endParaRPr lang="en-US" sz="1000" dirty="0"/>
           </a:p>
           <a:p>
-            <a:pPr indent="0" marL="0">
+            <a:pPr marL="0" indent="0">
               <a:buNone/>
             </a:pPr>
             <a:r>
@@ -4567,7 +4502,7 @@
             <a:endParaRPr lang="en-US" sz="1000" dirty="0"/>
           </a:p>
           <a:p>
-            <a:pPr indent="0" marL="0">
+            <a:pPr marL="0" indent="0">
               <a:buNone/>
             </a:pPr>
             <a:r>
@@ -4584,7 +4519,7 @@
             <a:endParaRPr lang="en-US" sz="1000" dirty="0"/>
           </a:p>
           <a:p>
-            <a:pPr indent="0" marL="0">
+            <a:pPr marL="0" indent="0">
               <a:buNone/>
             </a:pPr>
             <a:r>
@@ -4601,7 +4536,7 @@
             <a:endParaRPr lang="en-US" sz="1000" dirty="0"/>
           </a:p>
           <a:p>
-            <a:pPr indent="0" marL="0">
+            <a:pPr marL="0" indent="0">
               <a:buNone/>
             </a:pPr>
             <a:r>
@@ -4618,7 +4553,7 @@
             <a:endParaRPr lang="en-US" sz="1000" dirty="0"/>
           </a:p>
           <a:p>
-            <a:pPr indent="0" marL="0">
+            <a:pPr marL="0" indent="0">
               <a:buNone/>
             </a:pPr>
             <a:r>
@@ -4635,7 +4570,7 @@
             <a:endParaRPr lang="en-US" sz="1000" dirty="0"/>
           </a:p>
           <a:p>
-            <a:pPr indent="0" marL="0">
+            <a:pPr marL="0" indent="0">
               <a:buNone/>
             </a:pPr>
             <a:r>
@@ -4652,7 +4587,7 @@
             <a:endParaRPr lang="en-US" sz="1000" dirty="0"/>
           </a:p>
           <a:p>
-            <a:pPr indent="0" marL="0">
+            <a:pPr marL="0" indent="0">
               <a:buNone/>
             </a:pPr>
             <a:r>
@@ -4669,7 +4604,7 @@
             <a:endParaRPr lang="en-US" sz="1000" dirty="0"/>
           </a:p>
           <a:p>
-            <a:pPr indent="0" marL="0">
+            <a:pPr marL="0" indent="0">
               <a:buNone/>
             </a:pPr>
             <a:r>
@@ -4686,7 +4621,7 @@
             <a:endParaRPr lang="en-US" sz="1000" dirty="0"/>
           </a:p>
           <a:p>
-            <a:pPr indent="0" marL="0">
+            <a:pPr marL="0" indent="0">
               <a:buNone/>
             </a:pPr>
             <a:r>
@@ -4703,7 +4638,7 @@
             <a:endParaRPr lang="en-US" sz="1000" dirty="0"/>
           </a:p>
           <a:p>
-            <a:pPr indent="0" marL="0">
+            <a:pPr marL="0" indent="0">
               <a:buNone/>
             </a:pPr>
             <a:r>
@@ -4720,7 +4655,7 @@
             <a:endParaRPr lang="en-US" sz="1000" dirty="0"/>
           </a:p>
           <a:p>
-            <a:pPr indent="0" marL="0">
+            <a:pPr marL="0" indent="0">
               <a:buNone/>
             </a:pPr>
             <a:r>
@@ -4737,7 +4672,7 @@
             <a:endParaRPr lang="en-US" sz="1000" dirty="0"/>
           </a:p>
           <a:p>
-            <a:pPr indent="0" marL="0">
+            <a:pPr marL="0" indent="0">
               <a:buNone/>
             </a:pPr>
             <a:r>
@@ -4754,7 +4689,7 @@
             <a:endParaRPr lang="en-US" sz="1000" dirty="0"/>
           </a:p>
           <a:p>
-            <a:pPr indent="0" marL="0">
+            <a:pPr marL="0" indent="0">
               <a:buNone/>
             </a:pPr>
             <a:r>
@@ -4771,7 +4706,7 @@
             <a:endParaRPr lang="en-US" sz="1000" dirty="0"/>
           </a:p>
           <a:p>
-            <a:pPr indent="0" marL="0">
+            <a:pPr marL="0" indent="0">
               <a:buNone/>
             </a:pPr>
             <a:r>
@@ -4788,7 +4723,7 @@
             <a:endParaRPr lang="en-US" sz="1000" dirty="0"/>
           </a:p>
           <a:p>
-            <a:pPr indent="0" marL="0">
+            <a:pPr marL="0" indent="0">
               <a:buNone/>
             </a:pPr>
             <a:r>
@@ -4805,7 +4740,7 @@
             <a:endParaRPr lang="en-US" sz="1000" dirty="0"/>
           </a:p>
           <a:p>
-            <a:pPr indent="0" marL="0">
+            <a:pPr marL="0" indent="0">
               <a:buNone/>
             </a:pPr>
             <a:r>
@@ -4847,6 +4782,13 @@
             <a:prstDash val="solid"/>
           </a:ln>
         </p:spPr>
+        <p:txBody>
+          <a:bodyPr/>
+          <a:lstStyle/>
+          <a:p>
+            <a:endParaRPr lang="en-AE"/>
+          </a:p>
+        </p:txBody>
       </p:sp>
       <p:sp>
         <p:nvSpPr>
@@ -4869,7 +4811,7 @@
           <a:bodyPr wrap="square" lIns="0" tIns="0" rIns="0" bIns="0" rtlCol="0" anchor="t"/>
           <a:lstStyle/>
           <a:p>
-            <a:pPr indent="0" marL="0">
+            <a:pPr marL="0" indent="0">
               <a:spcAft>
                 <a:spcPts val="300"/>
               </a:spcAft>
@@ -4889,7 +4831,7 @@
             <a:endParaRPr lang="en-US" sz="1400" dirty="0"/>
           </a:p>
           <a:p>
-            <a:pPr indent="0" marL="0">
+            <a:pPr marL="0" indent="0">
               <a:spcAft>
                 <a:spcPts val="300"/>
               </a:spcAft>
@@ -4906,7 +4848,7 @@
             <a:endParaRPr lang="en-US" sz="1400" dirty="0"/>
           </a:p>
           <a:p>
-            <a:pPr indent="0" marL="0">
+            <a:pPr marL="0" indent="0">
               <a:spcAft>
                 <a:spcPts val="300"/>
               </a:spcAft>
@@ -4951,6 +4893,13 @@
             <a:prstDash val="solid"/>
           </a:ln>
         </p:spPr>
+        <p:txBody>
+          <a:bodyPr/>
+          <a:lstStyle/>
+          <a:p>
+            <a:endParaRPr lang="en-AE"/>
+          </a:p>
+        </p:txBody>
       </p:sp>
       <p:sp>
         <p:nvSpPr>
@@ -4973,7 +4922,7 @@
           <a:bodyPr wrap="square" lIns="0" tIns="0" rIns="0" bIns="0" rtlCol="0" anchor="t"/>
           <a:lstStyle/>
           <a:p>
-            <a:pPr indent="0" marL="0">
+            <a:pPr marL="0" indent="0">
               <a:spcAft>
                 <a:spcPts val="300"/>
               </a:spcAft>
@@ -4993,7 +4942,7 @@
             <a:endParaRPr lang="en-US" sz="1400" dirty="0"/>
           </a:p>
           <a:p>
-            <a:pPr indent="0" marL="0">
+            <a:pPr marL="0" indent="0">
               <a:spcAft>
                 <a:spcPts val="300"/>
               </a:spcAft>
@@ -5010,7 +4959,7 @@
             <a:endParaRPr lang="en-US" sz="1400" dirty="0"/>
           </a:p>
           <a:p>
-            <a:pPr indent="0" marL="0">
+            <a:pPr marL="0" indent="0">
               <a:spcAft>
                 <a:spcPts val="300"/>
               </a:spcAft>
@@ -5052,7 +5001,7 @@
           <a:bodyPr wrap="square" lIns="0" tIns="0" rIns="0" bIns="0" rtlCol="0" anchor="t"/>
           <a:lstStyle/>
           <a:p>
-            <a:pPr indent="0" marL="0">
+            <a:pPr marL="0" indent="0">
               <a:buNone/>
             </a:pPr>
             <a:r>
@@ -5087,7 +5036,7 @@
           </a:prstGeom>
           <a:extLst>
             <a:ext uri="{C572A759-6A51-4108-AA02-DFA0A04FC94B}">
-              <ma14:wrappingTextBoxFlag xmlns:ma14="http://schemas.microsoft.com/office/mac/drawingml/2011/main" val="0"/>
+              <ma14:wrappingTextBoxFlag xmlns:ma14="http://schemas.microsoft.com/office/mac/drawingml/2011/main" xmlns="" val="0"/>
             </a:ext>
           </a:extLst>
         </p:spPr>
@@ -5105,7 +5054,7 @@
           <a:p>
             <a:pPr algn="r"/>
             <a:fld id="{F7021451-1387-4CA6-816F-3879F97B5CBC}" type="slidenum">
-              <a:rPr b="0" lang="en-US"/>
+              <a:rPr lang="en-US" b="0"/>
               <a:t>5</a:t>
             </a:fld>
             <a:endParaRPr lang="en-US"/>
@@ -5140,9 +5089,11 @@
       <p:sp>
         <p:nvSpPr>
           <p:cNvPr id="2" name="Text 0"/>
-          <p:cNvSpPr/>
+          <p:cNvSpPr>
+            <a:spLocks noGrp="1"/>
+          </p:cNvSpPr>
           <p:nvPr>
-            <p:ph idx="100" type="title" hasCustomPrompt="1"/>
+            <p:ph type="title" idx="100" hasCustomPrompt="1"/>
           </p:nvPr>
         </p:nvSpPr>
         <p:spPr>
@@ -5160,7 +5111,7 @@
           <a:bodyPr wrap="square" lIns="0" tIns="0" rIns="0" bIns="0" rtlCol="0" anchor="ctr"/>
           <a:lstStyle/>
           <a:p>
-            <a:pPr algn="l" indent="0" marL="0">
+            <a:pPr marL="0" indent="0" algn="l">
               <a:buNone/>
             </a:pPr>
             <a:r>
@@ -5199,7 +5150,7 @@
           <a:bodyPr wrap="square" lIns="0" tIns="0" rIns="0" bIns="0" rtlCol="0" anchor="t"/>
           <a:lstStyle/>
           <a:p>
-            <a:pPr indent="0" marL="0">
+            <a:pPr marL="0" indent="0">
               <a:buNone/>
             </a:pPr>
             <a:r>
@@ -5216,141 +5167,7 @@
       </p:sp>
       <p:pic>
         <p:nvPicPr>
-          <p:cNvPr id="4" name="While it looks through the fleet" descr="While it looks through the fleet">    </p:cNvPr>
-          <p:cNvPicPr>
-            <a:picLocks noChangeAspect="1"/>
-          </p:cNvPicPr>
-          <p:nvPr/>
-        </p:nvPicPr>
-        <p:blipFill>
-          <a:blip r:embed="rId1"/>
-          <a:stretch>
-            <a:fillRect/>
-          </a:stretch>
-        </p:blipFill>
-        <p:spPr>
-          <a:xfrm>
-            <a:off x="457200" y="1371600"/>
-            <a:ext cx="1874520" cy="3017520"/>
-          </a:xfrm>
-          <a:prstGeom prst="rect">
-            <a:avLst/>
-          </a:prstGeom>
-          <a:effectLst>
-            <a:outerShdw sx="100000" sy="100000" kx="0" ky="0" algn="bl" rotWithShape="0" blurRad="127000" dist="38100" dir="5400000">
-              <a:srgbClr val="1A1A1A">
-                <a:alpha val="28000"/>
-              </a:srgbClr>
-            </a:outerShdw>
-          </a:effectLst>
-        </p:spPr>
-      </p:pic>
-      <p:sp>
-        <p:nvSpPr>
-          <p:cNvPr id="5" name="Caption 1"/>
-          <p:cNvSpPr txBox="1"/>
-          <p:nvPr/>
-        </p:nvSpPr>
-        <p:spPr>
-          <a:xfrm>
-            <a:off x="457200" y="4434840"/>
-            <a:ext cx="2148840" cy="274320"/>
-          </a:xfrm>
-          <a:prstGeom prst="rect">
-            <a:avLst/>
-          </a:prstGeom>
-          <a:noFill/>
-          <a:ln/>
-        </p:spPr>
-        <p:txBody>
-          <a:bodyPr wrap="square" lIns="0" tIns="0" rIns="0" bIns="0" rtlCol="0" anchor="ctr"/>
-          <a:lstStyle/>
-          <a:p>
-            <a:pPr indent="0" marL="0">
-              <a:buNone/>
-            </a:pPr>
-            <a:r>
-              <a:rPr lang="en-US" sz="1100" dirty="0">
-                <a:solidFill>
-                  <a:schemeClr val="tx1"/>
-                </a:solidFill>
-              </a:rPr>
-              <a:t>1  While it looks through the fleet</a:t>
-            </a:r>
-            <a:endParaRPr lang="en-US" sz="1100" dirty="0"/>
-          </a:p>
-        </p:txBody>
-      </p:sp>
-      <p:pic>
-        <p:nvPicPr>
-          <p:cNvPr id="6" name="Three cars, real prices, linked" descr="Three cars, real prices, linked">    </p:cNvPr>
-          <p:cNvPicPr>
-            <a:picLocks noChangeAspect="1"/>
-          </p:cNvPicPr>
-          <p:nvPr/>
-        </p:nvPicPr>
-        <p:blipFill>
-          <a:blip r:embed="rId2"/>
-          <a:stretch>
-            <a:fillRect/>
-          </a:stretch>
-        </p:blipFill>
-        <p:spPr>
-          <a:xfrm>
-            <a:off x="2743200" y="1371600"/>
-            <a:ext cx="1874520" cy="3017520"/>
-          </a:xfrm>
-          <a:prstGeom prst="rect">
-            <a:avLst/>
-          </a:prstGeom>
-          <a:effectLst>
-            <a:outerShdw sx="100000" sy="100000" kx="0" ky="0" algn="bl" rotWithShape="0" blurRad="127000" dist="38100" dir="5400000">
-              <a:srgbClr val="1A1A1A">
-                <a:alpha val="28000"/>
-              </a:srgbClr>
-            </a:outerShdw>
-          </a:effectLst>
-        </p:spPr>
-      </p:pic>
-      <p:sp>
-        <p:nvSpPr>
-          <p:cNvPr id="7" name="Caption 2"/>
-          <p:cNvSpPr txBox="1"/>
-          <p:nvPr/>
-        </p:nvSpPr>
-        <p:spPr>
-          <a:xfrm>
-            <a:off x="2743200" y="4434840"/>
-            <a:ext cx="2148840" cy="274320"/>
-          </a:xfrm>
-          <a:prstGeom prst="rect">
-            <a:avLst/>
-          </a:prstGeom>
-          <a:noFill/>
-          <a:ln/>
-        </p:spPr>
-        <p:txBody>
-          <a:bodyPr wrap="square" lIns="0" tIns="0" rIns="0" bIns="0" rtlCol="0" anchor="ctr"/>
-          <a:lstStyle/>
-          <a:p>
-            <a:pPr indent="0" marL="0">
-              <a:buNone/>
-            </a:pPr>
-            <a:r>
-              <a:rPr lang="en-US" sz="1100" dirty="0">
-                <a:solidFill>
-                  <a:schemeClr val="tx1"/>
-                </a:solidFill>
-              </a:rPr>
-              <a:t>2  Three cars, real prices, linked</a:t>
-            </a:r>
-            <a:endParaRPr lang="en-US" sz="1100" dirty="0"/>
-          </a:p>
-        </p:txBody>
-      </p:sp>
-      <p:pic>
-        <p:nvPicPr>
-          <p:cNvPr id="8" name="Dates checked and priced" descr="Dates checked and priced">    </p:cNvPr>
+          <p:cNvPr id="4" name="While it looks through the fleet" descr="While it looks through the fleet"/>
           <p:cNvPicPr>
             <a:picLocks noChangeAspect="1"/>
           </p:cNvPicPr>
@@ -5364,14 +5181,14 @@
         </p:blipFill>
         <p:spPr>
           <a:xfrm>
-            <a:off x="5029200" y="1371600"/>
+            <a:off x="457200" y="1371600"/>
             <a:ext cx="1874520" cy="3017520"/>
           </a:xfrm>
           <a:prstGeom prst="rect">
             <a:avLst/>
           </a:prstGeom>
           <a:effectLst>
-            <a:outerShdw sx="100000" sy="100000" kx="0" ky="0" algn="bl" rotWithShape="0" blurRad="127000" dist="38100" dir="5400000">
+            <a:outerShdw blurRad="127000" dist="38100" dir="5400000" algn="bl" rotWithShape="0">
               <a:srgbClr val="1A1A1A">
                 <a:alpha val="28000"/>
               </a:srgbClr>
@@ -5381,13 +5198,13 @@
       </p:pic>
       <p:sp>
         <p:nvSpPr>
-          <p:cNvPr id="9" name="Caption 3"/>
+          <p:cNvPr id="5" name="Caption 1"/>
           <p:cNvSpPr txBox="1"/>
           <p:nvPr/>
         </p:nvSpPr>
         <p:spPr>
           <a:xfrm>
-            <a:off x="5029200" y="4434840"/>
+            <a:off x="457200" y="4434840"/>
             <a:ext cx="2148840" cy="274320"/>
           </a:xfrm>
           <a:prstGeom prst="rect">
@@ -5400,7 +5217,7 @@
           <a:bodyPr wrap="square" lIns="0" tIns="0" rIns="0" bIns="0" rtlCol="0" anchor="ctr"/>
           <a:lstStyle/>
           <a:p>
-            <a:pPr indent="0" marL="0">
+            <a:pPr marL="0" indent="0">
               <a:buNone/>
             </a:pPr>
             <a:r>
@@ -5409,7 +5226,7 @@
                   <a:schemeClr val="tx1"/>
                 </a:solidFill>
               </a:rPr>
-              <a:t>3  Dates checked and priced</a:t>
+              <a:t>1  While it looks through the fleet</a:t>
             </a:r>
             <a:endParaRPr lang="en-US" sz="1100" dirty="0"/>
           </a:p>
@@ -5417,7 +5234,7 @@
       </p:sp>
       <p:pic>
         <p:nvPicPr>
-          <p:cNvPr id="10" name="On a phone" descr="On a phone">    </p:cNvPr>
+          <p:cNvPr id="6" name="Three cars, real prices, linked" descr="Three cars, real prices, linked"/>
           <p:cNvPicPr>
             <a:picLocks noChangeAspect="1"/>
           </p:cNvPicPr>
@@ -5431,14 +5248,14 @@
         </p:blipFill>
         <p:spPr>
           <a:xfrm>
-            <a:off x="7315200" y="1371600"/>
-            <a:ext cx="1389888" cy="3017520"/>
+            <a:off x="2743200" y="1371600"/>
+            <a:ext cx="1874520" cy="3017520"/>
           </a:xfrm>
           <a:prstGeom prst="rect">
             <a:avLst/>
           </a:prstGeom>
           <a:effectLst>
-            <a:outerShdw sx="100000" sy="100000" kx="0" ky="0" algn="bl" rotWithShape="0" blurRad="127000" dist="38100" dir="5400000">
+            <a:outerShdw blurRad="127000" dist="38100" dir="5400000" algn="bl" rotWithShape="0">
               <a:srgbClr val="1A1A1A">
                 <a:alpha val="28000"/>
               </a:srgbClr>
@@ -5448,6 +5265,140 @@
       </p:pic>
       <p:sp>
         <p:nvSpPr>
+          <p:cNvPr id="7" name="Caption 2"/>
+          <p:cNvSpPr txBox="1"/>
+          <p:nvPr/>
+        </p:nvSpPr>
+        <p:spPr>
+          <a:xfrm>
+            <a:off x="2743200" y="4434840"/>
+            <a:ext cx="2148840" cy="274320"/>
+          </a:xfrm>
+          <a:prstGeom prst="rect">
+            <a:avLst/>
+          </a:prstGeom>
+          <a:noFill/>
+          <a:ln/>
+        </p:spPr>
+        <p:txBody>
+          <a:bodyPr wrap="square" lIns="0" tIns="0" rIns="0" bIns="0" rtlCol="0" anchor="ctr"/>
+          <a:lstStyle/>
+          <a:p>
+            <a:pPr marL="0" indent="0">
+              <a:buNone/>
+            </a:pPr>
+            <a:r>
+              <a:rPr lang="en-US" sz="1100" dirty="0">
+                <a:solidFill>
+                  <a:schemeClr val="tx1"/>
+                </a:solidFill>
+              </a:rPr>
+              <a:t>2  Three cars, real prices, linked</a:t>
+            </a:r>
+            <a:endParaRPr lang="en-US" sz="1100" dirty="0"/>
+          </a:p>
+        </p:txBody>
+      </p:sp>
+      <p:pic>
+        <p:nvPicPr>
+          <p:cNvPr id="8" name="Dates checked and priced" descr="Dates checked and priced"/>
+          <p:cNvPicPr>
+            <a:picLocks noChangeAspect="1"/>
+          </p:cNvPicPr>
+          <p:nvPr/>
+        </p:nvPicPr>
+        <p:blipFill>
+          <a:blip r:embed="rId5"/>
+          <a:stretch>
+            <a:fillRect/>
+          </a:stretch>
+        </p:blipFill>
+        <p:spPr>
+          <a:xfrm>
+            <a:off x="5029200" y="1371600"/>
+            <a:ext cx="1874520" cy="3017520"/>
+          </a:xfrm>
+          <a:prstGeom prst="rect">
+            <a:avLst/>
+          </a:prstGeom>
+          <a:effectLst>
+            <a:outerShdw blurRad="127000" dist="38100" dir="5400000" algn="bl" rotWithShape="0">
+              <a:srgbClr val="1A1A1A">
+                <a:alpha val="28000"/>
+              </a:srgbClr>
+            </a:outerShdw>
+          </a:effectLst>
+        </p:spPr>
+      </p:pic>
+      <p:sp>
+        <p:nvSpPr>
+          <p:cNvPr id="9" name="Caption 3"/>
+          <p:cNvSpPr txBox="1"/>
+          <p:nvPr/>
+        </p:nvSpPr>
+        <p:spPr>
+          <a:xfrm>
+            <a:off x="5029200" y="4434840"/>
+            <a:ext cx="2148840" cy="274320"/>
+          </a:xfrm>
+          <a:prstGeom prst="rect">
+            <a:avLst/>
+          </a:prstGeom>
+          <a:noFill/>
+          <a:ln/>
+        </p:spPr>
+        <p:txBody>
+          <a:bodyPr wrap="square" lIns="0" tIns="0" rIns="0" bIns="0" rtlCol="0" anchor="ctr"/>
+          <a:lstStyle/>
+          <a:p>
+            <a:pPr marL="0" indent="0">
+              <a:buNone/>
+            </a:pPr>
+            <a:r>
+              <a:rPr lang="en-US" sz="1100" dirty="0">
+                <a:solidFill>
+                  <a:schemeClr val="tx1"/>
+                </a:solidFill>
+              </a:rPr>
+              <a:t>3  Dates checked and priced</a:t>
+            </a:r>
+            <a:endParaRPr lang="en-US" sz="1100" dirty="0"/>
+          </a:p>
+        </p:txBody>
+      </p:sp>
+      <p:pic>
+        <p:nvPicPr>
+          <p:cNvPr id="10" name="On a phone" descr="On a phone"/>
+          <p:cNvPicPr>
+            <a:picLocks noChangeAspect="1"/>
+          </p:cNvPicPr>
+          <p:nvPr/>
+        </p:nvPicPr>
+        <p:blipFill>
+          <a:blip r:embed="rId6"/>
+          <a:stretch>
+            <a:fillRect/>
+          </a:stretch>
+        </p:blipFill>
+        <p:spPr>
+          <a:xfrm>
+            <a:off x="7315200" y="1371600"/>
+            <a:ext cx="1389888" cy="3017520"/>
+          </a:xfrm>
+          <a:prstGeom prst="rect">
+            <a:avLst/>
+          </a:prstGeom>
+          <a:effectLst>
+            <a:outerShdw blurRad="127000" dist="38100" dir="5400000" algn="bl" rotWithShape="0">
+              <a:srgbClr val="1A1A1A">
+                <a:alpha val="28000"/>
+              </a:srgbClr>
+            </a:outerShdw>
+          </a:effectLst>
+        </p:spPr>
+      </p:pic>
+      <p:sp>
+        <p:nvSpPr>
           <p:cNvPr id="11" name="Caption 4"/>
           <p:cNvSpPr txBox="1"/>
           <p:nvPr/>
@@ -5467,7 +5418,7 @@
           <a:bodyPr wrap="square" lIns="0" tIns="0" rIns="0" bIns="0" rtlCol="0" anchor="ctr"/>
           <a:lstStyle/>
           <a:p>
-            <a:pPr indent="0" marL="0">
+            <a:pPr marL="0" indent="0">
               <a:buNone/>
             </a:pPr>
             <a:r>
@@ -5502,7 +5453,7 @@
           </a:prstGeom>
           <a:extLst>
             <a:ext uri="{C572A759-6A51-4108-AA02-DFA0A04FC94B}">
-              <ma14:wrappingTextBoxFlag xmlns:ma14="http://schemas.microsoft.com/office/mac/drawingml/2011/main" val="0"/>
+              <ma14:wrappingTextBoxFlag xmlns:ma14="http://schemas.microsoft.com/office/mac/drawingml/2011/main" xmlns="" val="0"/>
             </a:ext>
           </a:extLst>
         </p:spPr>
@@ -5520,7 +5471,7 @@
           <a:p>
             <a:pPr algn="r"/>
             <a:fld id="{F7021451-1387-4CA6-816F-3879F97B5CBC}" type="slidenum">
-              <a:rPr b="0" lang="en-US"/>
+              <a:rPr lang="en-US" b="0"/>
               <a:t>6</a:t>
             </a:fld>
             <a:endParaRPr lang="en-US"/>
@@ -5555,9 +5506,11 @@
       <p:sp>
         <p:nvSpPr>
           <p:cNvPr id="2" name="Text 0"/>
-          <p:cNvSpPr/>
+          <p:cNvSpPr>
+            <a:spLocks noGrp="1"/>
+          </p:cNvSpPr>
           <p:nvPr>
-            <p:ph idx="100" type="title" hasCustomPrompt="1"/>
+            <p:ph type="title" idx="100" hasCustomPrompt="1"/>
           </p:nvPr>
         </p:nvSpPr>
         <p:spPr>
@@ -5575,7 +5528,7 @@
           <a:bodyPr wrap="square" lIns="0" tIns="0" rIns="0" bIns="0" rtlCol="0" anchor="ctr"/>
           <a:lstStyle/>
           <a:p>
-            <a:pPr algn="l" indent="0" marL="0">
+            <a:pPr marL="0" indent="0" algn="l">
               <a:buNone/>
             </a:pPr>
             <a:r>
@@ -5744,7 +5697,7 @@
           <a:bodyPr wrap="square" lIns="0" tIns="0" rIns="0" bIns="0" rtlCol="0" anchor="ctr"/>
           <a:lstStyle/>
           <a:p>
-            <a:pPr indent="0" marL="0">
+            <a:pPr marL="0" indent="0">
               <a:buNone/>
             </a:pPr>
             <a:r>
@@ -5783,7 +5736,7 @@
           <a:bodyPr wrap="square" lIns="0" tIns="0" rIns="0" bIns="0" rtlCol="0" anchor="ctr"/>
           <a:lstStyle/>
           <a:p>
-            <a:pPr indent="0" marL="0">
+            <a:pPr marL="0" indent="0">
               <a:buNone/>
             </a:pPr>
             <a:r>
@@ -5819,7 +5772,7 @@
           <a:bodyPr wrap="square" lIns="0" tIns="0" rIns="0" bIns="0" rtlCol="0" anchor="ctr"/>
           <a:lstStyle/>
           <a:p>
-            <a:pPr indent="0" marL="0">
+            <a:pPr marL="0" indent="0">
               <a:buNone/>
             </a:pPr>
             <a:r>
@@ -5858,7 +5811,7 @@
           <a:bodyPr wrap="square" lIns="0" tIns="0" rIns="0" bIns="0" rtlCol="0" anchor="ctr"/>
           <a:lstStyle/>
           <a:p>
-            <a:pPr indent="0" marL="0">
+            <a:pPr marL="0" indent="0">
               <a:buNone/>
             </a:pPr>
             <a:r>
@@ -5897,6 +5850,13 @@
             <a:prstDash val="solid"/>
           </a:ln>
         </p:spPr>
+        <p:txBody>
+          <a:bodyPr/>
+          <a:lstStyle/>
+          <a:p>
+            <a:endParaRPr lang="en-AE"/>
+          </a:p>
+        </p:txBody>
       </p:sp>
       <p:sp>
         <p:nvSpPr>
@@ -5919,7 +5879,7 @@
           <a:bodyPr wrap="square" lIns="0" tIns="0" rIns="0" bIns="0" rtlCol="0" anchor="t"/>
           <a:lstStyle/>
           <a:p>
-            <a:pPr indent="0" marL="0">
+            <a:pPr marL="0" indent="0">
               <a:buNone/>
             </a:pPr>
             <a:r>
@@ -5933,7 +5893,7 @@
             <a:endParaRPr lang="en-US" sz="1300" dirty="0"/>
           </a:p>
           <a:p>
-            <a:pPr indent="0" marL="0">
+            <a:pPr marL="0" indent="0">
               <a:buNone/>
             </a:pPr>
             <a:r>
@@ -5968,7 +5928,7 @@
           </a:prstGeom>
           <a:extLst>
             <a:ext uri="{C572A759-6A51-4108-AA02-DFA0A04FC94B}">
-              <ma14:wrappingTextBoxFlag xmlns:ma14="http://schemas.microsoft.com/office/mac/drawingml/2011/main" val="0"/>
+              <ma14:wrappingTextBoxFlag xmlns:ma14="http://schemas.microsoft.com/office/mac/drawingml/2011/main" xmlns="" val="0"/>
             </a:ext>
           </a:extLst>
         </p:spPr>
@@ -5986,7 +5946,7 @@
           <a:p>
             <a:pPr algn="r"/>
             <a:fld id="{F7021451-1387-4CA6-816F-3879F97B5CBC}" type="slidenum">
-              <a:rPr b="0" lang="en-US"/>
+              <a:rPr lang="en-US" b="0"/>
               <a:t>7</a:t>
             </a:fld>
             <a:endParaRPr lang="en-US"/>
@@ -6294,4 +6254,319 @@
     </a:ext>
   </a:extLst>
 </a:theme>
+</file>
+
+<file path=ppt/theme/theme2.xml><?xml version="1.0" encoding="utf-8"?>
+<a:theme xmlns:a="http://schemas.openxmlformats.org/drawingml/2006/main" name="Office Theme">
+  <a:themeElements>
+    <a:clrScheme name="Office">
+      <a:dk1>
+        <a:sysClr val="windowText" lastClr="000000"/>
+      </a:dk1>
+      <a:lt1>
+        <a:sysClr val="window" lastClr="FFFFFF"/>
+      </a:lt1>
+      <a:dk2>
+        <a:srgbClr val="0E2841"/>
+      </a:dk2>
+      <a:lt2>
+        <a:srgbClr val="E8E8E8"/>
+      </a:lt2>
+      <a:accent1>
+        <a:srgbClr val="156082"/>
+      </a:accent1>
+      <a:accent2>
+        <a:srgbClr val="E97132"/>
+      </a:accent2>
+      <a:accent3>
+        <a:srgbClr val="196B24"/>
+      </a:accent3>
+      <a:accent4>
+        <a:srgbClr val="0F9ED5"/>
+      </a:accent4>
+      <a:accent5>
+        <a:srgbClr val="A02B93"/>
+      </a:accent5>
+      <a:accent6>
+        <a:srgbClr val="4EA72E"/>
+      </a:accent6>
+      <a:hlink>
+        <a:srgbClr val="467886"/>
+      </a:hlink>
+      <a:folHlink>
+        <a:srgbClr val="96607D"/>
+      </a:folHlink>
+    </a:clrScheme>
+    <a:fontScheme name="Office">
+      <a:majorFont>
+        <a:latin typeface="Aptos Display" panose="02110004020202020204"/>
+        <a:ea typeface=""/>
+        <a:cs typeface=""/>
+        <a:font script="Jpan" typeface="游ゴシック Light"/>
+        <a:font script="Hang" typeface="맑은 고딕"/>
+        <a:font script="Hans" typeface="等线 Light"/>
+        <a:font script="Hant" typeface="新細明體"/>
+        <a:font script="Arab" typeface="Times New Roman"/>
+        <a:font script="Hebr" typeface="Times New Roman"/>
+        <a:font script="Thai" typeface="Angsana New"/>
+        <a:font script="Ethi" typeface="Nyala"/>
+        <a:font script="Beng" typeface="Vrinda"/>
+        <a:font script="Gujr" typeface="Shruti"/>
+        <a:font script="Khmr" typeface="MoolBoran"/>
+        <a:font script="Knda" typeface="Tunga"/>
+        <a:font script="Guru" typeface="Raavi"/>
+        <a:font script="Cans" typeface="Euphemia"/>
+        <a:font script="Cher" typeface="Plantagenet Cherokee"/>
+        <a:font script="Yiii" typeface="Microsoft Yi Baiti"/>
+        <a:font script="Tibt" typeface="Microsoft Himalaya"/>
+        <a:font script="Thaa" typeface="MV Boli"/>
+        <a:font script="Deva" typeface="Mangal"/>
+        <a:font script="Telu" typeface="Gautami"/>
+        <a:font script="Taml" typeface="Latha"/>
+        <a:font script="Syrc" typeface="Estrangelo Edessa"/>
+        <a:font script="Orya" typeface="Kalinga"/>
+        <a:font script="Mlym" typeface="Kartika"/>
+        <a:font script="Laoo" typeface="DokChampa"/>
+        <a:font script="Sinh" typeface="Iskoola Pota"/>
+        <a:font script="Mong" typeface="Mongolian Baiti"/>
+        <a:font script="Viet" typeface="Times New Roman"/>
+        <a:font script="Uigh" typeface="Microsoft Uighur"/>
+        <a:font script="Geor" typeface="Sylfaen"/>
+        <a:font script="Armn" typeface="Arial"/>
+        <a:font script="Bugi" typeface="Leelawadee UI"/>
+        <a:font script="Bopo" typeface="Microsoft JhengHei"/>
+        <a:font script="Java" typeface="Javanese Text"/>
+        <a:font script="Lisu" typeface="Segoe UI"/>
+        <a:font script="Mymr" typeface="Myanmar Text"/>
+        <a:font script="Nkoo" typeface="Ebrima"/>
+        <a:font script="Olck" typeface="Nirmala UI"/>
+        <a:font script="Osma" typeface="Ebrima"/>
+        <a:font script="Phag" typeface="Phagspa"/>
+        <a:font script="Syrn" typeface="Estrangelo Edessa"/>
+        <a:font script="Syrj" typeface="Estrangelo Edessa"/>
+        <a:font script="Syre" typeface="Estrangelo Edessa"/>
+        <a:font script="Sora" typeface="Nirmala UI"/>
+        <a:font script="Tale" typeface="Microsoft Tai Le"/>
+        <a:font script="Talu" typeface="Microsoft New Tai Lue"/>
+        <a:font script="Tfng" typeface="Ebrima"/>
+      </a:majorFont>
+      <a:minorFont>
+        <a:latin typeface="Aptos" panose="02110004020202020204"/>
+        <a:ea typeface=""/>
+        <a:cs typeface=""/>
+        <a:font script="Jpan" typeface="游ゴシック"/>
+        <a:font script="Hang" typeface="맑은 고딕"/>
+        <a:font script="Hans" typeface="等线"/>
+        <a:font script="Hant" typeface="新細明體"/>
+        <a:font script="Arab" typeface="Arial"/>
+        <a:font script="Hebr" typeface="Arial"/>
+        <a:font script="Thai" typeface="Cordia New"/>
+        <a:font script="Ethi" typeface="Nyala"/>
+        <a:font script="Beng" typeface="Vrinda"/>
+        <a:font script="Gujr" typeface="Shruti"/>
+        <a:font script="Khmr" typeface="DaunPenh"/>
+        <a:font script="Knda" typeface="Tunga"/>
+        <a:font script="Guru" typeface="Raavi"/>
+        <a:font script="Cans" typeface="Euphemia"/>
+        <a:font script="Cher" typeface="Plantagenet Cherokee"/>
+        <a:font script="Yiii" typeface="Microsoft Yi Baiti"/>
+        <a:font script="Tibt" typeface="Microsoft Himalaya"/>
+        <a:font script="Thaa" typeface="MV Boli"/>
+        <a:font script="Deva" typeface="Mangal"/>
+        <a:font script="Telu" typeface="Gautami"/>
+        <a:font script="Taml" typeface="Latha"/>
+        <a:font script="Syrc" typeface="Estrangelo Edessa"/>
+        <a:font script="Orya" typeface="Kalinga"/>
+        <a:font script="Mlym" typeface="Kartika"/>
+        <a:font script="Laoo" typeface="DokChampa"/>
+        <a:font script="Sinh" typeface="Iskoola Pota"/>
+        <a:font script="Mong" typeface="Mongolian Baiti"/>
+        <a:font script="Viet" typeface="Arial"/>
+        <a:font script="Uigh" typeface="Microsoft Uighur"/>
+        <a:font script="Geor" typeface="Sylfaen"/>
+        <a:font script="Armn" typeface="Arial"/>
+        <a:font script="Bugi" typeface="Leelawadee UI"/>
+        <a:font script="Bopo" typeface="Microsoft JhengHei"/>
+        <a:font script="Java" typeface="Javanese Text"/>
+        <a:font script="Lisu" typeface="Segoe UI"/>
+        <a:font script="Mymr" typeface="Myanmar Text"/>
+        <a:font script="Nkoo" typeface="Ebrima"/>
+        <a:font script="Olck" typeface="Nirmala UI"/>
+        <a:font script="Osma" typeface="Ebrima"/>
+        <a:font script="Phag" typeface="Phagspa"/>
+        <a:font script="Syrn" typeface="Estrangelo Edessa"/>
+        <a:font script="Syrj" typeface="Estrangelo Edessa"/>
+        <a:font script="Syre" typeface="Estrangelo Edessa"/>
+        <a:font script="Sora" typeface="Nirmala UI"/>
+        <a:font script="Tale" typeface="Microsoft Tai Le"/>
+        <a:font script="Talu" typeface="Microsoft New Tai Lue"/>
+        <a:font script="Tfng" typeface="Ebrima"/>
+      </a:minorFont>
+    </a:fontScheme>
+    <a:fmtScheme name="Office">
+      <a:fillStyleLst>
+        <a:solidFill>
+          <a:schemeClr val="phClr"/>
+        </a:solidFill>
+        <a:gradFill rotWithShape="1">
+          <a:gsLst>
+            <a:gs pos="0">
+              <a:schemeClr val="phClr">
+                <a:lumMod val="110000"/>
+                <a:satMod val="105000"/>
+                <a:tint val="67000"/>
+              </a:schemeClr>
+            </a:gs>
+            <a:gs pos="50000">
+              <a:schemeClr val="phClr">
+                <a:lumMod val="105000"/>
+                <a:satMod val="103000"/>
+                <a:tint val="73000"/>
+              </a:schemeClr>
+            </a:gs>
+            <a:gs pos="100000">
+              <a:schemeClr val="phClr">
+                <a:lumMod val="105000"/>
+                <a:satMod val="109000"/>
+                <a:tint val="81000"/>
+              </a:schemeClr>
+            </a:gs>
+          </a:gsLst>
+          <a:lin ang="5400000" scaled="0"/>
+        </a:gradFill>
+        <a:gradFill rotWithShape="1">
+          <a:gsLst>
+            <a:gs pos="0">
+              <a:schemeClr val="phClr">
+                <a:satMod val="103000"/>
+                <a:lumMod val="102000"/>
+                <a:tint val="94000"/>
+              </a:schemeClr>
+            </a:gs>
+            <a:gs pos="50000">
+              <a:schemeClr val="phClr">
+                <a:satMod val="110000"/>
+                <a:lumMod val="100000"/>
+                <a:shade val="100000"/>
+              </a:schemeClr>
+            </a:gs>
+            <a:gs pos="100000">
+              <a:schemeClr val="phClr">
+                <a:lumMod val="99000"/>
+                <a:satMod val="120000"/>
+                <a:shade val="78000"/>
+              </a:schemeClr>
+            </a:gs>
+          </a:gsLst>
+          <a:lin ang="5400000" scaled="0"/>
+        </a:gradFill>
+      </a:fillStyleLst>
+      <a:lnStyleLst>
+        <a:ln w="12700" cap="flat" cmpd="sng" algn="ctr">
+          <a:solidFill>
+            <a:schemeClr val="phClr"/>
+          </a:solidFill>
+          <a:prstDash val="solid"/>
+          <a:miter lim="800000"/>
+        </a:ln>
+        <a:ln w="19050" cap="flat" cmpd="sng" algn="ctr">
+          <a:solidFill>
+            <a:schemeClr val="phClr"/>
+          </a:solidFill>
+          <a:prstDash val="solid"/>
+          <a:miter lim="800000"/>
+        </a:ln>
+        <a:ln w="25400" cap="flat" cmpd="sng" algn="ctr">
+          <a:solidFill>
+            <a:schemeClr val="phClr"/>
+          </a:solidFill>
+          <a:prstDash val="solid"/>
+          <a:miter lim="800000"/>
+        </a:ln>
+      </a:lnStyleLst>
+      <a:effectStyleLst>
+        <a:effectStyle>
+          <a:effectLst/>
+        </a:effectStyle>
+        <a:effectStyle>
+          <a:effectLst/>
+        </a:effectStyle>
+        <a:effectStyle>
+          <a:effectLst>
+            <a:outerShdw blurRad="57150" dist="19050" dir="5400000" algn="ctr" rotWithShape="0">
+              <a:srgbClr val="000000">
+                <a:alpha val="63000"/>
+              </a:srgbClr>
+            </a:outerShdw>
+          </a:effectLst>
+        </a:effectStyle>
+      </a:effectStyleLst>
+      <a:bgFillStyleLst>
+        <a:solidFill>
+          <a:schemeClr val="phClr"/>
+        </a:solidFill>
+        <a:solidFill>
+          <a:schemeClr val="phClr">
+            <a:tint val="95000"/>
+            <a:satMod val="170000"/>
+          </a:schemeClr>
+        </a:solidFill>
+        <a:gradFill rotWithShape="1">
+          <a:gsLst>
+            <a:gs pos="0">
+              <a:schemeClr val="phClr">
+                <a:tint val="93000"/>
+                <a:satMod val="150000"/>
+                <a:shade val="98000"/>
+                <a:lumMod val="102000"/>
+              </a:schemeClr>
+            </a:gs>
+            <a:gs pos="50000">
+              <a:schemeClr val="phClr">
+                <a:tint val="98000"/>
+                <a:satMod val="130000"/>
+                <a:shade val="90000"/>
+                <a:lumMod val="103000"/>
+              </a:schemeClr>
+            </a:gs>
+            <a:gs pos="100000">
+              <a:schemeClr val="phClr">
+                <a:shade val="63000"/>
+                <a:satMod val="120000"/>
+              </a:schemeClr>
+            </a:gs>
+          </a:gsLst>
+          <a:lin ang="5400000" scaled="0"/>
+        </a:gradFill>
+      </a:bgFillStyleLst>
+    </a:fmtScheme>
+  </a:themeElements>
+  <a:objectDefaults>
+    <a:lnDef>
+      <a:spPr/>
+      <a:bodyPr/>
+      <a:lstStyle/>
+      <a:style>
+        <a:lnRef idx="2">
+          <a:schemeClr val="accent1"/>
+        </a:lnRef>
+        <a:fillRef idx="0">
+          <a:schemeClr val="accent1"/>
+        </a:fillRef>
+        <a:effectRef idx="1">
+          <a:schemeClr val="accent1"/>
+        </a:effectRef>
+        <a:fontRef idx="minor">
+          <a:schemeClr val="tx1"/>
+        </a:fontRef>
+      </a:style>
+    </a:lnDef>
+  </a:objectDefaults>
+  <a:extraClrSchemeLst/>
+  <a:extLst>
+    <a:ext uri="{05A4C25C-085E-4340-85A3-A5531E510DB2}">
+      <thm15:themeFamily xmlns:thm15="http://schemas.microsoft.com/office/thememl/2012/main" name="Office Theme" id="{2E142A2C-CD16-42D6-873A-C26D2A0506FA}" vid="{1BDDFF52-6CD6-40A5-AB3C-68EB2F1E4D0A}"/>
+    </a:ext>
+  </a:extLst>
+</a:theme>
 </file>
</xml_diff>